<commit_message>
Rework technical support slide: SECUKOREA 24/7 remote support with SK shieldus escalation
Co-Authored-By: Claude Opus 5.5 <noreply@anthropic.com>
Claude-Session: https://claude.ai/code/session_01AC58wvp3ibSdWMcWgRepkj
</commit_message>
<xml_diff>
--- a/ENG._Nessus_vs_CrowdStrike_Falcon_Proposal_for_Westin_Resort_Guam_SECUKOREA.pptx
+++ b/ENG._Nessus_vs_CrowdStrike_Falcon_Proposal_for_Westin_Resort_Guam_SECUKOREA.pptx
@@ -1666,7 +1666,7 @@
           <a:p>
             <a:r>
               <a:rPr lang="en-US" dirty="0"/>
-              <a:t>SECUKOREA provides local technical support throughout the engagement: helpdesk, deployment and policy tuning, incident analysis assistance, license management, health checks, reporting and training. The resort has one partner to call, with escalation to CrowdStrike when needed.</a:t>
+              <a:t>SECUKOREA is the first line of support: 24/7 remote technical support tailored to overseas sites, and a dedicated engineer matched to the resort for stable day-to-day operation. When deeper help is needed, CrowdStrike partner SK shieldus provides escalation support: 24/7 incident response specialists, a 30-minute call and 2-hour initial response SLA for critical events, investigation across network devices and servers, correlation with other security logs, and malware analysis.</a:t>
             </a:r>
             <a:endParaRPr lang="en-US" dirty="0"/>
           </a:p>
@@ -14639,7 +14639,7 @@
                 <a:ea typeface="Calibri" pitchFamily="34" charset="-122"/>
                 <a:cs typeface="Calibri" pitchFamily="34" charset="-120"/>
               </a:rPr>
-              <a:t>Deployment, policy tuning, local coordination and regular reporting</a:t>
+              <a:t>24/7 remote support, dedicated engineer and regular reporting</a:t>
             </a:r>
             <a:endParaRPr lang="en-US" sz="1250" dirty="0"/>
           </a:p>
@@ -21976,7 +21976,7 @@
                 <a:ea typeface="Arial" pitchFamily="34" charset="-122"/>
                 <a:cs typeface="Arial" pitchFamily="34" charset="-120"/>
               </a:rPr>
-              <a:t>SECUKOREA Technical Support</a:t>
+              <a:t>SECUKOREA 24/7 Technical Support</a:t>
             </a:r>
             <a:endParaRPr lang="en-US" sz="2800" dirty="0"/>
           </a:p>
@@ -22090,7 +22090,7 @@
                 <a:ea typeface="Arial" pitchFamily="34" charset="-122"/>
                 <a:cs typeface="Arial" pitchFamily="34" charset="-120"/>
               </a:rPr>
-              <a:t>Dedicated Technical Helpdesk</a:t>
+              <a:t>24/7 Remote Support for Overseas Sites</a:t>
             </a:r>
             <a:endParaRPr lang="en-US" sz="1500" dirty="0"/>
           </a:p>
@@ -22129,7 +22129,7 @@
                 <a:ea typeface="Calibri" pitchFamily="34" charset="-122"/>
                 <a:cs typeface="Calibri" pitchFamily="34" charset="-120"/>
               </a:rPr>
-              <a:t>One SECUKOREA contact by email and phone for questions, issues and changes — escalated to CrowdStrike when needed.</a:t>
+              <a:t>Round-the-clock remote support built for overseas operations — help is available regardless of time zone or local business hours.</a:t>
             </a:r>
             <a:endParaRPr lang="en-US" sz="1200" dirty="0"/>
           </a:p>
@@ -22219,7 +22219,7 @@
                 <a:ea typeface="Arial" pitchFamily="34" charset="-122"/>
                 <a:cs typeface="Arial" pitchFamily="34" charset="-120"/>
               </a:rPr>
-              <a:t>Deployment &amp; Policy Tuning</a:t>
+              <a:t>Dedicated Engineer Matching</a:t>
             </a:r>
             <a:endParaRPr lang="en-US" sz="1500" dirty="0"/>
           </a:p>
@@ -22258,7 +22258,7 @@
                 <a:ea typeface="Calibri" pitchFamily="34" charset="-122"/>
                 <a:cs typeface="Calibri" pitchFamily="34" charset="-120"/>
               </a:rPr>
-              <a:t>SECUKOREA engineers plan the sensor rollout, configure prevention policies and tune exclusions for hotel applications such as PMS and POS.</a:t>
+              <a:t>A named SECUKOREA engineer who knows the resort’s environment handles rollout, policy tuning and day-to-day requests.</a:t>
             </a:r>
             <a:endParaRPr lang="en-US" sz="1200" dirty="0"/>
           </a:p>
@@ -22348,7 +22348,7 @@
                 <a:ea typeface="Arial" pitchFamily="34" charset="-122"/>
                 <a:cs typeface="Arial" pitchFamily="34" charset="-120"/>
               </a:rPr>
-              <a:t>Incident Analysis &amp; Response Assistance</a:t>
+              <a:t>Stable, Well-Maintained Operations</a:t>
             </a:r>
             <a:endParaRPr lang="en-US" sz="1500" dirty="0"/>
           </a:p>
@@ -22387,7 +22387,7 @@
                 <a:ea typeface="Calibri" pitchFamily="34" charset="-122"/>
                 <a:cs typeface="Calibri" pitchFamily="34" charset="-120"/>
               </a:rPr>
-              <a:t>We help review detections, investigate alerts and coordinate containment and recovery steps together with the resort’s IT team.</a:t>
+              <a:t>Regular health checks of sensors, policies and updates, with reports to management, to keep the system running reliably.</a:t>
             </a:r>
             <a:endParaRPr lang="en-US" sz="1200" dirty="0"/>
           </a:p>
@@ -22477,7 +22477,7 @@
                 <a:ea typeface="Arial" pitchFamily="34" charset="-122"/>
                 <a:cs typeface="Arial" pitchFamily="34" charset="-120"/>
               </a:rPr>
-              <a:t>License &amp; Contract Management</a:t>
+              <a:t>One Point of Contact</a:t>
             </a:r>
             <a:endParaRPr lang="en-US" sz="1500" dirty="0"/>
           </a:p>
@@ -22516,7 +22516,7 @@
                 <a:ea typeface="Calibri" pitchFamily="34" charset="-122"/>
                 <a:cs typeface="Calibri" pitchFamily="34" charset="-120"/>
               </a:rPr>
-              <a:t>One point of contact for licensing, renewals and module additions, and for coordination with CrowdStrike and its MDR team.</a:t>
+              <a:t>Support, licensing and renewals through one partner, with escalation to SK shieldus and CrowdStrike when needed.</a:t>
             </a:r>
             <a:endParaRPr lang="en-US" sz="1200" dirty="0"/>
           </a:p>
@@ -22582,7 +22582,7 @@
                 <a:ea typeface="Calibri" pitchFamily="34" charset="-122"/>
                 <a:cs typeface="Calibri" pitchFamily="34" charset="-120"/>
               </a:rPr>
-              <a:t>WHAT SECUKOREA PROVIDES</a:t>
+              <a:t>ESCALATION  ·  SK SHIELDUS</a:t>
             </a:r>
             <a:endParaRPr lang="en-US" sz="1100" dirty="0"/>
           </a:p>
@@ -22645,7 +22645,7 @@
                 <a:ea typeface="Calibri" pitchFamily="34" charset="-122"/>
                 <a:cs typeface="Calibri" pitchFamily="34" charset="-120"/>
               </a:rPr>
-              <a:t>Remote installation and configuration support</a:t>
+              <a:t>Incident response specialists on duty 24/7</a:t>
             </a:r>
             <a:endParaRPr lang="en-US" sz="1300" dirty="0"/>
           </a:p>
@@ -22708,7 +22708,7 @@
                 <a:ea typeface="Calibri" pitchFamily="34" charset="-122"/>
                 <a:cs typeface="Calibri" pitchFamily="34" charset="-120"/>
               </a:rPr>
-              <a:t>Sensor update and version management</a:t>
+              <a:t>Critical alerts: call within 30 min, first action within 2 hrs (SLA)</a:t>
             </a:r>
             <a:endParaRPr lang="en-US" sz="1300" dirty="0"/>
           </a:p>
@@ -22771,7 +22771,7 @@
                 <a:ea typeface="Calibri" pitchFamily="34" charset="-122"/>
                 <a:cs typeface="Calibri" pitchFamily="34" charset="-120"/>
               </a:rPr>
-              <a:t>Regular health checks and security reports</a:t>
+              <a:t>Investigation across network devices and servers</a:t>
             </a:r>
             <a:endParaRPr lang="en-US" sz="1300" dirty="0"/>
           </a:p>
@@ -22834,7 +22834,7 @@
                 <a:ea typeface="Calibri" pitchFamily="34" charset="-122"/>
                 <a:cs typeface="Calibri" pitchFamily="34" charset="-120"/>
               </a:rPr>
-              <a:t>Operator training for the IT team</a:t>
+              <a:t>EDR events correlated with other security logs</a:t>
             </a:r>
             <a:endParaRPr lang="en-US" sz="1300" dirty="0"/>
           </a:p>
@@ -22897,7 +22897,7 @@
                 <a:ea typeface="Calibri" pitchFamily="34" charset="-122"/>
                 <a:cs typeface="Calibri" pitchFamily="34" charset="-120"/>
               </a:rPr>
-              <a:t>Coordination with CrowdStrike support</a:t>
+              <a:t>Malware analysis by experienced IR analysts</a:t>
             </a:r>
             <a:endParaRPr lang="en-US" sz="1300" dirty="0"/>
           </a:p>
@@ -22936,7 +22936,7 @@
                 <a:ea typeface="Calibri" pitchFamily="34" charset="-122"/>
                 <a:cs typeface="Calibri" pitchFamily="34" charset="-120"/>
               </a:rPr>
-              <a:t>One local partner, from pilot to day-to-day operations.</a:t>
+              <a:t>When needed, CrowdStrike partner SK shieldus steps in.</a:t>
             </a:r>
             <a:endParaRPr lang="en-US" sz="1400" dirty="0"/>
           </a:p>

</xml_diff>

<commit_message>
Limit proposed scope to Falcon Prevent + Insight; remove roadmap and next-steps slides
Co-Authored-By: Claude Opus 5.5 <noreply@anthropic.com>
Claude-Session: https://claude.ai/code/session_01AC58wvp3ibSdWMcWgRepkj
</commit_message>
<xml_diff>
--- a/ENG._Nessus_vs_CrowdStrike_Falcon_Proposal_for_Westin_Resort_Guam_SECUKOREA.pptx
+++ b/ENG._Nessus_vs_CrowdStrike_Falcon_Proposal_for_Westin_Resort_Guam_SECUKOREA.pptx
@@ -23,10 +23,8 @@
     <p:sldId id="269" r:id="rId15"/>
     <p:sldId id="270" r:id="rId16"/>
     <p:sldId id="271" r:id="rId17"/>
-    <p:sldId id="272" r:id="rId18"/>
     <p:sldId id="276" r:id="rId19"/>
     <p:sldId id="273" r:id="rId20"/>
-    <p:sldId id="274" r:id="rId21"/>
     <p:sldId id="275" r:id="rId22"/>
   </p:sldIdLst>
   <p:sldSz cx="12192000" cy="6858000"/>
@@ -389,7 +387,7 @@
           <a:p>
             <a:r>
               <a:rPr lang="en-US" dirty="0"/>
-              <a:t>The proposed scope is Falcon Prevent, Insight XDR, Device Control and Firewall Management, backed by SECUKOREA’s 24/7 remote technical support and a dedicated engineer. Final endpoint count will be confirmed after the scoping workshop.</a:t>
+              <a:t>The proposal covers two Falcon licenses: Falcon Prevent (next-gen antivirus) and Falcon Insight (EDR), both on the same single sensor. They are backed by SECUKOREA’s 24/7 remote technical support and a dedicated engineer.</a:t>
             </a:r>
           </a:p>
         </p:txBody>
@@ -865,93 +863,6 @@
 </p:notes>
 </file>
 
-<file path=ppt/notesSlides/notesSlide17.xml><?xml version="1.0" encoding="utf-8"?>
-<p:notes xmlns:a="http://schemas.openxmlformats.org/drawingml/2006/main" xmlns:r="http://schemas.openxmlformats.org/officeDocument/2006/relationships" xmlns:p="http://schemas.openxmlformats.org/presentationml/2006/main">
-  <p:cSld>
-    <p:spTree>
-      <p:nvGrpSpPr>
-        <p:cNvPr id="1" name=""/>
-        <p:cNvGrpSpPr/>
-        <p:nvPr/>
-      </p:nvGrpSpPr>
-      <p:grpSpPr>
-        <a:xfrm>
-          <a:off x="0" y="0"/>
-          <a:ext cx="0" cy="0"/>
-          <a:chOff x="0" y="0"/>
-          <a:chExt cx="0" cy="0"/>
-        </a:xfrm>
-      </p:grpSpPr>
-      <p:sp>
-        <p:nvSpPr>
-          <p:cNvPr id="2" name="Slide Image Placeholder 1"/>
-          <p:cNvSpPr>
-            <a:spLocks noGrp="1" noRot="1" noChangeAspect="1"/>
-          </p:cNvSpPr>
-          <p:nvPr>
-            <p:ph type="sldImg"/>
-          </p:nvPr>
-        </p:nvSpPr>
-        <p:spPr/>
-      </p:sp>
-      <p:sp>
-        <p:nvSpPr>
-          <p:cNvPr id="3" name="Notes Placeholder 2"/>
-          <p:cNvSpPr>
-            <a:spLocks noGrp="1"/>
-          </p:cNvSpPr>
-          <p:nvPr>
-            <p:ph type="body" idx="1"/>
-          </p:nvPr>
-        </p:nvSpPr>
-        <p:spPr/>
-        <p:txBody>
-          <a:bodyPr/>
-          <a:lstStyle/>
-          <a:p>
-            <a:r>
-              <a:rPr lang="en-US" dirty="0"/>
-              <a:t>Indicative schedule. A short pilot in detect-only mode protects hotel operations before prevention is switched on. Sensor updates are staged so the pilot group always receives them first.</a:t>
-            </a:r>
-          </a:p>
-        </p:txBody>
-      </p:sp>
-      <p:sp>
-        <p:nvSpPr>
-          <p:cNvPr id="4" name="Slide Number Placeholder 3"/>
-          <p:cNvSpPr>
-            <a:spLocks noGrp="1"/>
-          </p:cNvSpPr>
-          <p:nvPr>
-            <p:ph type="sldNum" sz="quarter" idx="10"/>
-          </p:nvPr>
-        </p:nvSpPr>
-        <p:spPr/>
-        <p:txBody>
-          <a:bodyPr/>
-          <a:lstStyle/>
-          <a:p>
-            <a:fld id="{F7021451-1387-4CA6-816F-3879F97B5CBC}" type="slidenum">
-              <a:rPr lang="en-US"/>
-              <a:t>17</a:t>
-            </a:fld>
-            <a:endParaRPr lang="en-US"/>
-          </a:p>
-        </p:txBody>
-      </p:sp>
-    </p:spTree>
-    <p:extLst>
-      <p:ext uri="{BB962C8B-B14F-4D97-AF65-F5344CB8AC3E}">
-        <p14:creationId xmlns:p14="http://schemas.microsoft.com/office/powerpoint/2010/main" val="1024086991"/>
-      </p:ext>
-    </p:extLst>
-  </p:cSld>
-  <p:clrMapOvr>
-    <a:masterClrMapping/>
-  </p:clrMapOvr>
-</p:notes>
-</file>
-
 <file path=ppt/notesSlides/notesSlide18.xml><?xml version="1.0" encoding="utf-8"?>
 <p:notes xmlns:a="http://schemas.openxmlformats.org/drawingml/2006/main" xmlns:r="http://schemas.openxmlformats.org/officeDocument/2006/relationships" xmlns:p="http://schemas.openxmlformats.org/presentationml/2006/main">
   <p:cSld>
@@ -1213,93 +1124,6 @@
 </p:notes>
 </file>
 
-<file path=ppt/notesSlides/notesSlide20.xml><?xml version="1.0" encoding="utf-8"?>
-<p:notes xmlns:a="http://schemas.openxmlformats.org/drawingml/2006/main" xmlns:r="http://schemas.openxmlformats.org/officeDocument/2006/relationships" xmlns:p="http://schemas.openxmlformats.org/presentationml/2006/main">
-  <p:cSld>
-    <p:spTree>
-      <p:nvGrpSpPr>
-        <p:cNvPr id="1" name=""/>
-        <p:cNvGrpSpPr/>
-        <p:nvPr/>
-      </p:nvGrpSpPr>
-      <p:grpSpPr>
-        <a:xfrm>
-          <a:off x="0" y="0"/>
-          <a:ext cx="0" cy="0"/>
-          <a:chOff x="0" y="0"/>
-          <a:chExt cx="0" cy="0"/>
-        </a:xfrm>
-      </p:grpSpPr>
-      <p:sp>
-        <p:nvSpPr>
-          <p:cNvPr id="2" name="Slide Image Placeholder 1"/>
-          <p:cNvSpPr>
-            <a:spLocks noGrp="1" noRot="1" noChangeAspect="1"/>
-          </p:cNvSpPr>
-          <p:nvPr>
-            <p:ph type="sldImg"/>
-          </p:nvPr>
-        </p:nvSpPr>
-        <p:spPr/>
-      </p:sp>
-      <p:sp>
-        <p:nvSpPr>
-          <p:cNvPr id="3" name="Notes Placeholder 2"/>
-          <p:cNvSpPr>
-            <a:spLocks noGrp="1"/>
-          </p:cNvSpPr>
-          <p:nvPr>
-            <p:ph type="body" idx="1"/>
-          </p:nvPr>
-        </p:nvSpPr>
-        <p:spPr/>
-        <p:txBody>
-          <a:bodyPr/>
-          <a:lstStyle/>
-          <a:p>
-            <a:r>
-              <a:rPr lang="en-US" dirty="0"/>
-              <a:t>Close with a concrete, low-effort first step: a short scoping workshop, followed by a pilot so the resort can see Falcon working on its own endpoints before deciding on full rollout.</a:t>
-            </a:r>
-          </a:p>
-        </p:txBody>
-      </p:sp>
-      <p:sp>
-        <p:nvSpPr>
-          <p:cNvPr id="4" name="Slide Number Placeholder 3"/>
-          <p:cNvSpPr>
-            <a:spLocks noGrp="1"/>
-          </p:cNvSpPr>
-          <p:nvPr>
-            <p:ph type="sldNum" sz="quarter" idx="10"/>
-          </p:nvPr>
-        </p:nvSpPr>
-        <p:spPr/>
-        <p:txBody>
-          <a:bodyPr/>
-          <a:lstStyle/>
-          <a:p>
-            <a:fld id="{F7021451-1387-4CA6-816F-3879F97B5CBC}" type="slidenum">
-              <a:rPr lang="en-US"/>
-              <a:t>20</a:t>
-            </a:fld>
-            <a:endParaRPr lang="en-US"/>
-          </a:p>
-        </p:txBody>
-      </p:sp>
-    </p:spTree>
-    <p:extLst>
-      <p:ext uri="{BB962C8B-B14F-4D97-AF65-F5344CB8AC3E}">
-        <p14:creationId xmlns:p14="http://schemas.microsoft.com/office/powerpoint/2010/main" val="1024086991"/>
-      </p:ext>
-    </p:extLst>
-  </p:cSld>
-  <p:clrMapOvr>
-    <a:masterClrMapping/>
-  </p:clrMapOvr>
-</p:notes>
-</file>
-
 <file path=ppt/notesSlides/notesSlide21.xml><?xml version="1.0" encoding="utf-8"?>
 <p:notes xmlns:a="http://schemas.openxmlformats.org/drawingml/2006/main" xmlns:r="http://schemas.openxmlformats.org/officeDocument/2006/relationships" xmlns:p="http://schemas.openxmlformats.org/presentationml/2006/main">
   <p:cSld>
@@ -1346,7 +1170,7 @@
           <a:p>
             <a:r>
               <a:rPr lang="en-US" dirty="0"/>
-              <a:t>Thank the audience and open for questions. Offer to schedule the scoping workshop.</a:t>
+              <a:t>Thank the audience and open the floor for questions.</a:t>
             </a:r>
           </a:p>
         </p:txBody>
@@ -3010,7 +2834,7 @@
                 <a:ea typeface="Calibri" pitchFamily="34" charset="-122"/>
                 <a:cs typeface="Calibri" pitchFamily="34" charset="-120"/>
               </a:rPr>
-              <a:t>FALCON PROTECTION MODULES</a:t>
+              <a:t>FALCON LICENSES IN THIS PROPOSAL</a:t>
             </a:r>
             <a:endParaRPr lang="en-US" sz="1100" dirty="0"/>
           </a:p>
@@ -3025,7 +2849,7 @@
         <p:spPr>
           <a:xfrm>
             <a:off x="548640" y="1828800"/>
-            <a:ext cx="2567864" cy="1901952"/>
+            <a:ext cx="5410048" cy="1901952"/>
           </a:xfrm>
           <a:prstGeom prst="roundRect">
             <a:avLst>
@@ -3110,7 +2934,7 @@
         <p:spPr>
           <a:xfrm>
             <a:off x="1371600" y="2011680"/>
-            <a:ext cx="1607744" cy="548640"/>
+            <a:ext cx="4358488" cy="548640"/>
           </a:xfrm>
           <a:prstGeom prst="rect">
             <a:avLst/>
@@ -3149,7 +2973,7 @@
         <p:spPr>
           <a:xfrm>
             <a:off x="777240" y="2651760"/>
-            <a:ext cx="2110664" cy="219456"/>
+            <a:ext cx="4952848" cy="219456"/>
           </a:xfrm>
           <a:prstGeom prst="rect">
             <a:avLst/>
@@ -3173,7 +2997,7 @@
                 <a:ea typeface="Calibri" pitchFamily="34" charset="-122"/>
                 <a:cs typeface="Calibri" pitchFamily="34" charset="-120"/>
               </a:rPr>
-              <a:t>NEXT-GEN AV (EPP)</a:t>
+              <a:t>NEXT-GEN ANTIVIRUS (EPP)</a:t>
             </a:r>
             <a:endParaRPr lang="en-US" sz="950" dirty="0"/>
           </a:p>
@@ -3188,7 +3012,7 @@
         <p:spPr>
           <a:xfrm>
             <a:off x="777240" y="2898648"/>
-            <a:ext cx="2110664" cy="758952"/>
+            <a:ext cx="4952848" cy="758952"/>
           </a:xfrm>
           <a:prstGeom prst="rect">
             <a:avLst/>
@@ -3212,7 +3036,7 @@
                 <a:ea typeface="Calibri" pitchFamily="34" charset="-122"/>
                 <a:cs typeface="Calibri" pitchFamily="34" charset="-120"/>
               </a:rPr>
-              <a:t>AI/ML stops malware, fileless and zero-day attacks. 100% ransomware prevention in SE Labs testing.</a:t>
+              <a:t>AI/ML-based next-gen antivirus that stops malware, ransomware, fileless and zero-day attacks — online or offline. 100% ransomware prevention in SE Labs testing.</a:t>
             </a:r>
             <a:endParaRPr lang="en-US" sz="1100" dirty="0"/>
           </a:p>
@@ -3226,8 +3050,8 @@
         </p:nvSpPr>
         <p:spPr>
           <a:xfrm>
-            <a:off x="3390824" y="1828800"/>
-            <a:ext cx="2567864" cy="1901952"/>
+            <a:off x="6233008" y="1828800"/>
+            <a:ext cx="5410048" cy="1901952"/>
           </a:xfrm>
           <a:prstGeom prst="roundRect">
             <a:avLst>
@@ -3260,7 +3084,7 @@
         </p:nvSpPr>
         <p:spPr>
           <a:xfrm>
-            <a:off x="3619424" y="2057400"/>
+            <a:off x="6461608" y="2057400"/>
             <a:ext cx="457200" cy="457200"/>
           </a:xfrm>
           <a:prstGeom prst="roundRect">
@@ -3295,7 +3119,7 @@
         </p:blipFill>
         <p:spPr>
           <a:xfrm>
-            <a:off x="3720008" y="2157984"/>
+            <a:off x="6562192" y="2157984"/>
             <a:ext cx="256032" cy="256032"/>
           </a:xfrm>
           <a:prstGeom prst="rect">
@@ -3311,8 +3135,8 @@
         </p:nvSpPr>
         <p:spPr>
           <a:xfrm>
-            <a:off x="4213784" y="2011680"/>
-            <a:ext cx="1607744" cy="548640"/>
+            <a:off x="7055968" y="2011680"/>
+            <a:ext cx="4358488" cy="548640"/>
           </a:xfrm>
           <a:prstGeom prst="rect">
             <a:avLst/>
@@ -3336,7 +3160,7 @@
                 <a:ea typeface="Arial" pitchFamily="34" charset="-122"/>
                 <a:cs typeface="Arial" pitchFamily="34" charset="-120"/>
               </a:rPr>
-              <a:t>Falcon Insight XDR</a:t>
+              <a:t>Falcon Insight</a:t>
             </a:r>
             <a:endParaRPr lang="en-US" sz="1300" dirty="0"/>
           </a:p>
@@ -3350,8 +3174,8 @@
         </p:nvSpPr>
         <p:spPr>
           <a:xfrm>
-            <a:off x="3619424" y="2651760"/>
-            <a:ext cx="2110664" cy="219456"/>
+            <a:off x="6461608" y="2651760"/>
+            <a:ext cx="4952848" cy="219456"/>
           </a:xfrm>
           <a:prstGeom prst="rect">
             <a:avLst/>
@@ -3375,7 +3199,7 @@
                 <a:ea typeface="Calibri" pitchFamily="34" charset="-122"/>
                 <a:cs typeface="Calibri" pitchFamily="34" charset="-120"/>
               </a:rPr>
-              <a:t>DETECT &amp; RESPOND (EDR)</a:t>
+              <a:t>ENDPOINT DETECTION &amp; RESPONSE (EDR)</a:t>
             </a:r>
             <a:endParaRPr lang="en-US" sz="950" dirty="0"/>
           </a:p>
@@ -3389,8 +3213,8 @@
         </p:nvSpPr>
         <p:spPr>
           <a:xfrm>
-            <a:off x="3619424" y="2898648"/>
-            <a:ext cx="2110664" cy="758952"/>
+            <a:off x="6461608" y="2898648"/>
+            <a:ext cx="4952848" cy="758952"/>
           </a:xfrm>
           <a:prstGeom prst="rect">
             <a:avLst/>
@@ -3414,411 +3238,7 @@
                 <a:ea typeface="Calibri" pitchFamily="34" charset="-122"/>
                 <a:cs typeface="Calibri" pitchFamily="34" charset="-120"/>
               </a:rPr>
-              <a:t>Full attack visibility, one-click host containment, and 95% faster mean time to respond.</a:t>
-            </a:r>
-            <a:endParaRPr lang="en-US" sz="1100" dirty="0"/>
-          </a:p>
-        </p:txBody>
-      </p:sp>
-      <p:sp>
-        <p:nvSpPr>
-          <p:cNvPr id="18" name="Shape 13"/>
-          <p:cNvSpPr/>
-          <p:nvPr/>
-        </p:nvSpPr>
-        <p:spPr>
-          <a:xfrm>
-            <a:off x="6233008" y="1828800"/>
-            <a:ext cx="2567864" cy="1901952"/>
-          </a:xfrm>
-          <a:prstGeom prst="roundRect">
-            <a:avLst>
-              <a:gd name="adj" fmla="val 3846"/>
-            </a:avLst>
-          </a:prstGeom>
-          <a:solidFill>
-            <a:srgbClr val="FFFFFF"/>
-          </a:solidFill>
-          <a:ln w="12700">
-            <a:solidFill>
-              <a:srgbClr val="F2B8BB"/>
-            </a:solidFill>
-            <a:prstDash val="solid"/>
-          </a:ln>
-          <a:effectLst>
-            <a:outerShdw blurRad="101600" dist="25400" dir="5400000" algn="bl" rotWithShape="0">
-              <a:srgbClr val="000000">
-                <a:alpha val="10000"/>
-              </a:srgbClr>
-            </a:outerShdw>
-          </a:effectLst>
-        </p:spPr>
-      </p:sp>
-      <p:sp>
-        <p:nvSpPr>
-          <p:cNvPr id="19" name="Shape 14"/>
-          <p:cNvSpPr/>
-          <p:nvPr/>
-        </p:nvSpPr>
-        <p:spPr>
-          <a:xfrm>
-            <a:off x="6461608" y="2057400"/>
-            <a:ext cx="457200" cy="457200"/>
-          </a:xfrm>
-          <a:prstGeom prst="roundRect">
-            <a:avLst>
-              <a:gd name="adj" fmla="val 20000"/>
-            </a:avLst>
-          </a:prstGeom>
-          <a:solidFill>
-            <a:srgbClr val="E3202A"/>
-          </a:solidFill>
-          <a:ln w="12700">
-            <a:solidFill>
-              <a:srgbClr val="E3202A"/>
-            </a:solidFill>
-            <a:prstDash val="solid"/>
-          </a:ln>
-        </p:spPr>
-      </p:sp>
-      <p:pic>
-        <p:nvPicPr>
-          <p:cNvPr id="20" name="Image 3" descr="preencoded.png"/>
-          <p:cNvPicPr>
-            <a:picLocks noChangeAspect="1"/>
-          </p:cNvPicPr>
-          <p:nvPr/>
-        </p:nvPicPr>
-        <p:blipFill>
-          <a:blip r:embed="rId6"/>
-          <a:stretch>
-            <a:fillRect/>
-          </a:stretch>
-        </p:blipFill>
-        <p:spPr>
-          <a:xfrm>
-            <a:off x="6562192" y="2157984"/>
-            <a:ext cx="256032" cy="256032"/>
-          </a:xfrm>
-          <a:prstGeom prst="rect">
-            <a:avLst/>
-          </a:prstGeom>
-        </p:spPr>
-      </p:pic>
-      <p:sp>
-        <p:nvSpPr>
-          <p:cNvPr id="21" name="Text 15"/>
-          <p:cNvSpPr txBox="1"/>
-          <p:nvPr/>
-        </p:nvSpPr>
-        <p:spPr>
-          <a:xfrm>
-            <a:off x="7055968" y="2011680"/>
-            <a:ext cx="1607744" cy="548640"/>
-          </a:xfrm>
-          <a:prstGeom prst="rect">
-            <a:avLst/>
-          </a:prstGeom>
-          <a:noFill/>
-          <a:ln/>
-        </p:spPr>
-        <p:txBody>
-          <a:bodyPr wrap="square" lIns="0" tIns="0" rIns="0" bIns="0" rtlCol="0" anchor="ctr"/>
-          <a:lstStyle/>
-          <a:p>
-            <a:pPr marL="0" indent="0">
-              <a:buNone/>
-            </a:pPr>
-            <a:r>
-              <a:rPr lang="en-US" sz="1300" b="1" dirty="0">
-                <a:solidFill>
-                  <a:srgbClr val="151A21"/>
-                </a:solidFill>
-                <a:latin typeface="Arial" pitchFamily="34" charset="0"/>
-                <a:ea typeface="Arial" pitchFamily="34" charset="-122"/>
-                <a:cs typeface="Arial" pitchFamily="34" charset="-120"/>
-              </a:rPr>
-              <a:t>Falcon Device Control</a:t>
-            </a:r>
-            <a:endParaRPr lang="en-US" sz="1300" dirty="0"/>
-          </a:p>
-        </p:txBody>
-      </p:sp>
-      <p:sp>
-        <p:nvSpPr>
-          <p:cNvPr id="22" name="Text 16"/>
-          <p:cNvSpPr txBox="1"/>
-          <p:nvPr/>
-        </p:nvSpPr>
-        <p:spPr>
-          <a:xfrm>
-            <a:off x="6461608" y="2651760"/>
-            <a:ext cx="2110664" cy="219456"/>
-          </a:xfrm>
-          <a:prstGeom prst="rect">
-            <a:avLst/>
-          </a:prstGeom>
-          <a:noFill/>
-          <a:ln/>
-        </p:spPr>
-        <p:txBody>
-          <a:bodyPr wrap="square" lIns="0" tIns="0" rIns="0" bIns="0" rtlCol="0" anchor="t"/>
-          <a:lstStyle/>
-          <a:p>
-            <a:pPr marL="0" indent="0">
-              <a:buNone/>
-            </a:pPr>
-            <a:r>
-              <a:rPr lang="en-US" sz="950" b="1" kern="0" spc="100" dirty="0">
-                <a:solidFill>
-                  <a:srgbClr val="E3202A"/>
-                </a:solidFill>
-                <a:latin typeface="Calibri" pitchFamily="34" charset="0"/>
-                <a:ea typeface="Calibri" pitchFamily="34" charset="-122"/>
-                <a:cs typeface="Calibri" pitchFamily="34" charset="-120"/>
-              </a:rPr>
-              <a:t>USB &amp; REMOVABLE MEDIA</a:t>
-            </a:r>
-            <a:endParaRPr lang="en-US" sz="950" dirty="0"/>
-          </a:p>
-        </p:txBody>
-      </p:sp>
-      <p:sp>
-        <p:nvSpPr>
-          <p:cNvPr id="23" name="Text 17"/>
-          <p:cNvSpPr txBox="1"/>
-          <p:nvPr/>
-        </p:nvSpPr>
-        <p:spPr>
-          <a:xfrm>
-            <a:off x="6461608" y="2898648"/>
-            <a:ext cx="2110664" cy="758952"/>
-          </a:xfrm>
-          <a:prstGeom prst="rect">
-            <a:avLst/>
-          </a:prstGeom>
-          <a:noFill/>
-          <a:ln/>
-        </p:spPr>
-        <p:txBody>
-          <a:bodyPr wrap="square" lIns="0" tIns="0" rIns="0" bIns="0" rtlCol="0" anchor="t"/>
-          <a:lstStyle/>
-          <a:p>
-            <a:pPr marL="0" indent="0">
-              <a:buNone/>
-            </a:pPr>
-            <a:r>
-              <a:rPr lang="en-US" sz="1100" dirty="0">
-                <a:solidFill>
-                  <a:srgbClr val="5E6978"/>
-                </a:solidFill>
-                <a:latin typeface="Calibri" pitchFamily="34" charset="0"/>
-                <a:ea typeface="Calibri" pitchFamily="34" charset="-122"/>
-                <a:cs typeface="Calibri" pitchFamily="34" charset="-120"/>
-              </a:rPr>
-              <a:t>Granular control of USB devices to block malware entry and data loss.</a:t>
-            </a:r>
-            <a:endParaRPr lang="en-US" sz="1100" dirty="0"/>
-          </a:p>
-        </p:txBody>
-      </p:sp>
-      <p:sp>
-        <p:nvSpPr>
-          <p:cNvPr id="24" name="Shape 18"/>
-          <p:cNvSpPr/>
-          <p:nvPr/>
-        </p:nvSpPr>
-        <p:spPr>
-          <a:xfrm>
-            <a:off x="9075191" y="1828800"/>
-            <a:ext cx="2567864" cy="1901952"/>
-          </a:xfrm>
-          <a:prstGeom prst="roundRect">
-            <a:avLst>
-              <a:gd name="adj" fmla="val 3846"/>
-            </a:avLst>
-          </a:prstGeom>
-          <a:solidFill>
-            <a:srgbClr val="FFFFFF"/>
-          </a:solidFill>
-          <a:ln w="12700">
-            <a:solidFill>
-              <a:srgbClr val="F2B8BB"/>
-            </a:solidFill>
-            <a:prstDash val="solid"/>
-          </a:ln>
-          <a:effectLst>
-            <a:outerShdw blurRad="101600" dist="25400" dir="5400000" algn="bl" rotWithShape="0">
-              <a:srgbClr val="000000">
-                <a:alpha val="10000"/>
-              </a:srgbClr>
-            </a:outerShdw>
-          </a:effectLst>
-        </p:spPr>
-      </p:sp>
-      <p:sp>
-        <p:nvSpPr>
-          <p:cNvPr id="25" name="Shape 19"/>
-          <p:cNvSpPr/>
-          <p:nvPr/>
-        </p:nvSpPr>
-        <p:spPr>
-          <a:xfrm>
-            <a:off x="9303791" y="2057400"/>
-            <a:ext cx="457200" cy="457200"/>
-          </a:xfrm>
-          <a:prstGeom prst="roundRect">
-            <a:avLst>
-              <a:gd name="adj" fmla="val 20000"/>
-            </a:avLst>
-          </a:prstGeom>
-          <a:solidFill>
-            <a:srgbClr val="E3202A"/>
-          </a:solidFill>
-          <a:ln w="12700">
-            <a:solidFill>
-              <a:srgbClr val="E3202A"/>
-            </a:solidFill>
-            <a:prstDash val="solid"/>
-          </a:ln>
-        </p:spPr>
-      </p:sp>
-      <p:pic>
-        <p:nvPicPr>
-          <p:cNvPr id="26" name="Image 4" descr="preencoded.png"/>
-          <p:cNvPicPr>
-            <a:picLocks noChangeAspect="1"/>
-          </p:cNvPicPr>
-          <p:nvPr/>
-        </p:nvPicPr>
-        <p:blipFill>
-          <a:blip r:embed="rId7"/>
-          <a:stretch>
-            <a:fillRect/>
-          </a:stretch>
-        </p:blipFill>
-        <p:spPr>
-          <a:xfrm>
-            <a:off x="9404375" y="2157984"/>
-            <a:ext cx="256032" cy="256032"/>
-          </a:xfrm>
-          <a:prstGeom prst="rect">
-            <a:avLst/>
-          </a:prstGeom>
-        </p:spPr>
-      </p:pic>
-      <p:sp>
-        <p:nvSpPr>
-          <p:cNvPr id="27" name="Text 20"/>
-          <p:cNvSpPr txBox="1"/>
-          <p:nvPr/>
-        </p:nvSpPr>
-        <p:spPr>
-          <a:xfrm>
-            <a:off x="9898151" y="2011680"/>
-            <a:ext cx="1607744" cy="548640"/>
-          </a:xfrm>
-          <a:prstGeom prst="rect">
-            <a:avLst/>
-          </a:prstGeom>
-          <a:noFill/>
-          <a:ln/>
-        </p:spPr>
-        <p:txBody>
-          <a:bodyPr wrap="square" lIns="0" tIns="0" rIns="0" bIns="0" rtlCol="0" anchor="ctr"/>
-          <a:lstStyle/>
-          <a:p>
-            <a:pPr marL="0" indent="0">
-              <a:buNone/>
-            </a:pPr>
-            <a:r>
-              <a:rPr lang="en-US" sz="1300" b="1" dirty="0">
-                <a:solidFill>
-                  <a:srgbClr val="151A21"/>
-                </a:solidFill>
-                <a:latin typeface="Arial" pitchFamily="34" charset="0"/>
-                <a:ea typeface="Arial" pitchFamily="34" charset="-122"/>
-                <a:cs typeface="Arial" pitchFamily="34" charset="-120"/>
-              </a:rPr>
-              <a:t>Falcon Firewall Management</a:t>
-            </a:r>
-            <a:endParaRPr lang="en-US" sz="1300" dirty="0"/>
-          </a:p>
-        </p:txBody>
-      </p:sp>
-      <p:sp>
-        <p:nvSpPr>
-          <p:cNvPr id="28" name="Text 21"/>
-          <p:cNvSpPr txBox="1"/>
-          <p:nvPr/>
-        </p:nvSpPr>
-        <p:spPr>
-          <a:xfrm>
-            <a:off x="9303791" y="2651760"/>
-            <a:ext cx="2110664" cy="219456"/>
-          </a:xfrm>
-          <a:prstGeom prst="rect">
-            <a:avLst/>
-          </a:prstGeom>
-          <a:noFill/>
-          <a:ln/>
-        </p:spPr>
-        <p:txBody>
-          <a:bodyPr wrap="square" lIns="0" tIns="0" rIns="0" bIns="0" rtlCol="0" anchor="t"/>
-          <a:lstStyle/>
-          <a:p>
-            <a:pPr marL="0" indent="0">
-              <a:buNone/>
-            </a:pPr>
-            <a:r>
-              <a:rPr lang="en-US" sz="950" b="1" kern="0" spc="100" dirty="0">
-                <a:solidFill>
-                  <a:srgbClr val="E3202A"/>
-                </a:solidFill>
-                <a:latin typeface="Calibri" pitchFamily="34" charset="0"/>
-                <a:ea typeface="Calibri" pitchFamily="34" charset="-122"/>
-                <a:cs typeface="Calibri" pitchFamily="34" charset="-120"/>
-              </a:rPr>
-              <a:t>HOST FIREWALL</a:t>
-            </a:r>
-            <a:endParaRPr lang="en-US" sz="950" dirty="0"/>
-          </a:p>
-        </p:txBody>
-      </p:sp>
-      <p:sp>
-        <p:nvSpPr>
-          <p:cNvPr id="29" name="Text 22"/>
-          <p:cNvSpPr txBox="1"/>
-          <p:nvPr/>
-        </p:nvSpPr>
-        <p:spPr>
-          <a:xfrm>
-            <a:off x="9303791" y="2898648"/>
-            <a:ext cx="2110664" cy="758952"/>
-          </a:xfrm>
-          <a:prstGeom prst="rect">
-            <a:avLst/>
-          </a:prstGeom>
-          <a:noFill/>
-          <a:ln/>
-        </p:spPr>
-        <p:txBody>
-          <a:bodyPr wrap="square" lIns="0" tIns="0" rIns="0" bIns="0" rtlCol="0" anchor="t"/>
-          <a:lstStyle/>
-          <a:p>
-            <a:pPr marL="0" indent="0">
-              <a:buNone/>
-            </a:pPr>
-            <a:r>
-              <a:rPr lang="en-US" sz="1100" dirty="0">
-                <a:solidFill>
-                  <a:srgbClr val="5E6978"/>
-                </a:solidFill>
-                <a:latin typeface="Calibri" pitchFamily="34" charset="0"/>
-                <a:ea typeface="Calibri" pitchFamily="34" charset="-122"/>
-                <a:cs typeface="Calibri" pitchFamily="34" charset="-120"/>
-              </a:rPr>
-              <a:t>Simple firewall policies for Windows, macOS and Linux from the same console.</a:t>
+              <a:t>Continuous endpoint monitoring with full attack visibility, one-click host containment and remote response — 95% faster mean time to respond.</a:t>
             </a:r>
             <a:endParaRPr lang="en-US" sz="1100" dirty="0"/>
           </a:p>
@@ -13414,2344 +12834,6 @@
 </p:sld>
 </file>
 
-<file path=ppt/slides/slide17.xml><?xml version="1.0" encoding="utf-8"?>
-<p:sld xmlns:a="http://schemas.openxmlformats.org/drawingml/2006/main" xmlns:r="http://schemas.openxmlformats.org/officeDocument/2006/relationships" xmlns:p="http://schemas.openxmlformats.org/presentationml/2006/main">
-  <p:cSld name="Slide 17">
-    <p:bg>
-      <p:bgPr>
-        <a:solidFill>
-          <a:srgbClr val="FFFFFF"/>
-        </a:solidFill>
-        <a:effectLst/>
-      </p:bgPr>
-    </p:bg>
-    <p:spTree>
-      <p:nvGrpSpPr>
-        <p:cNvPr id="1" name=""/>
-        <p:cNvGrpSpPr/>
-        <p:nvPr/>
-      </p:nvGrpSpPr>
-      <p:grpSpPr>
-        <a:xfrm>
-          <a:off x="0" y="0"/>
-          <a:ext cx="0" cy="0"/>
-          <a:chOff x="0" y="0"/>
-          <a:chExt cx="0" cy="0"/>
-        </a:xfrm>
-      </p:grpSpPr>
-      <p:sp>
-        <p:nvSpPr>
-          <p:cNvPr id="2" name="Text 0"/>
-          <p:cNvSpPr txBox="1"/>
-          <p:nvPr/>
-        </p:nvSpPr>
-        <p:spPr>
-          <a:xfrm>
-            <a:off x="548640" y="384048"/>
-            <a:ext cx="8229600" cy="256032"/>
-          </a:xfrm>
-          <a:prstGeom prst="rect">
-            <a:avLst/>
-          </a:prstGeom>
-          <a:noFill/>
-          <a:ln/>
-        </p:spPr>
-        <p:txBody>
-          <a:bodyPr wrap="square" lIns="0" tIns="0" rIns="0" bIns="0" rtlCol="0" anchor="t"/>
-          <a:lstStyle/>
-          <a:p>
-            <a:pPr marL="0" indent="0">
-              <a:buNone/>
-            </a:pPr>
-            <a:r>
-              <a:rPr lang="en-US" sz="1100" b="1" kern="0" spc="200" dirty="0">
-                <a:solidFill>
-                  <a:srgbClr val="E3202A"/>
-                </a:solidFill>
-                <a:latin typeface="Arial" pitchFamily="34" charset="0"/>
-                <a:ea typeface="Arial" pitchFamily="34" charset="-122"/>
-                <a:cs typeface="Arial" pitchFamily="34" charset="-120"/>
-              </a:rPr>
-              <a:t>14   DEPLOYMENT PLAN</a:t>
-            </a:r>
-            <a:endParaRPr lang="en-US" sz="1100" dirty="0"/>
-          </a:p>
-        </p:txBody>
-      </p:sp>
-      <p:sp>
-        <p:nvSpPr>
-          <p:cNvPr id="3" name="Text 1"/>
-          <p:cNvSpPr txBox="1"/>
-          <p:nvPr/>
-        </p:nvSpPr>
-        <p:spPr>
-          <a:xfrm>
-            <a:off x="548640" y="658368"/>
-            <a:ext cx="9692640" cy="658368"/>
-          </a:xfrm>
-          <a:prstGeom prst="rect">
-            <a:avLst/>
-          </a:prstGeom>
-          <a:noFill/>
-          <a:ln/>
-        </p:spPr>
-        <p:txBody>
-          <a:bodyPr wrap="square" lIns="0" tIns="0" rIns="0" bIns="0" rtlCol="0" anchor="ctr"/>
-          <a:lstStyle/>
-          <a:p>
-            <a:pPr marL="0" indent="0">
-              <a:buNone/>
-            </a:pPr>
-            <a:r>
-              <a:rPr lang="en-US" sz="2800" b="1" dirty="0">
-                <a:solidFill>
-                  <a:srgbClr val="151A21"/>
-                </a:solidFill>
-                <a:latin typeface="Arial" pitchFamily="34" charset="0"/>
-                <a:ea typeface="Arial" pitchFamily="34" charset="-122"/>
-                <a:cs typeface="Arial" pitchFamily="34" charset="-120"/>
-              </a:rPr>
-              <a:t>Phased Deployment Roadmap</a:t>
-            </a:r>
-            <a:endParaRPr lang="en-US" sz="2800" dirty="0"/>
-          </a:p>
-        </p:txBody>
-      </p:sp>
-      <p:pic>
-        <p:nvPicPr>
-          <p:cNvPr id="4" name="Image 0" descr="/private/tmp/claude-501/-Users-jihanvin-Desktop-NIVNAH-AI/16a96446-d9b3-40e2-af9e-a3011ae3db84/scratchpad/assets/westin_grey.png"/>
-          <p:cNvPicPr>
-            <a:picLocks noChangeAspect="1"/>
-          </p:cNvPicPr>
-          <p:nvPr/>
-        </p:nvPicPr>
-        <p:blipFill>
-          <a:blip r:embed="rId3"/>
-          <a:stretch>
-            <a:fillRect/>
-          </a:stretch>
-        </p:blipFill>
-        <p:spPr>
-          <a:xfrm>
-            <a:off x="10634472" y="402336"/>
-            <a:ext cx="1005840" cy="301752"/>
-          </a:xfrm>
-          <a:prstGeom prst="rect">
-            <a:avLst/>
-          </a:prstGeom>
-        </p:spPr>
-      </p:pic>
-      <p:sp>
-        <p:nvSpPr>
-          <p:cNvPr id="5" name="Text 2"/>
-          <p:cNvSpPr txBox="1"/>
-          <p:nvPr/>
-        </p:nvSpPr>
-        <p:spPr>
-          <a:xfrm>
-            <a:off x="548640" y="1481328"/>
-            <a:ext cx="1849069" cy="237744"/>
-          </a:xfrm>
-          <a:prstGeom prst="rect">
-            <a:avLst/>
-          </a:prstGeom>
-          <a:noFill/>
-          <a:ln/>
-        </p:spPr>
-        <p:txBody>
-          <a:bodyPr wrap="square" lIns="0" tIns="0" rIns="0" bIns="0" rtlCol="0" anchor="t"/>
-          <a:lstStyle/>
-          <a:p>
-            <a:pPr marL="0" indent="0" algn="ctr">
-              <a:buNone/>
-            </a:pPr>
-            <a:r>
-              <a:rPr lang="en-US" sz="1000" b="1" dirty="0">
-                <a:solidFill>
-                  <a:srgbClr val="5E6978"/>
-                </a:solidFill>
-                <a:latin typeface="Calibri" pitchFamily="34" charset="0"/>
-                <a:ea typeface="Calibri" pitchFamily="34" charset="-122"/>
-                <a:cs typeface="Calibri" pitchFamily="34" charset="-120"/>
-              </a:rPr>
-              <a:t>W1</a:t>
-            </a:r>
-            <a:endParaRPr lang="en-US" sz="1000" dirty="0"/>
-          </a:p>
-        </p:txBody>
-      </p:sp>
-      <p:sp>
-        <p:nvSpPr>
-          <p:cNvPr id="6" name="Text 3"/>
-          <p:cNvSpPr txBox="1"/>
-          <p:nvPr/>
-        </p:nvSpPr>
-        <p:spPr>
-          <a:xfrm>
-            <a:off x="2397709" y="1481328"/>
-            <a:ext cx="1849069" cy="237744"/>
-          </a:xfrm>
-          <a:prstGeom prst="rect">
-            <a:avLst/>
-          </a:prstGeom>
-          <a:noFill/>
-          <a:ln/>
-        </p:spPr>
-        <p:txBody>
-          <a:bodyPr wrap="square" lIns="0" tIns="0" rIns="0" bIns="0" rtlCol="0" anchor="t"/>
-          <a:lstStyle/>
-          <a:p>
-            <a:pPr marL="0" indent="0" algn="ctr">
-              <a:buNone/>
-            </a:pPr>
-            <a:r>
-              <a:rPr lang="en-US" sz="1000" b="1" dirty="0">
-                <a:solidFill>
-                  <a:srgbClr val="5E6978"/>
-                </a:solidFill>
-                <a:latin typeface="Calibri" pitchFamily="34" charset="0"/>
-                <a:ea typeface="Calibri" pitchFamily="34" charset="-122"/>
-                <a:cs typeface="Calibri" pitchFamily="34" charset="-120"/>
-              </a:rPr>
-              <a:t>W2</a:t>
-            </a:r>
-            <a:endParaRPr lang="en-US" sz="1000" dirty="0"/>
-          </a:p>
-        </p:txBody>
-      </p:sp>
-      <p:sp>
-        <p:nvSpPr>
-          <p:cNvPr id="7" name="Text 4"/>
-          <p:cNvSpPr txBox="1"/>
-          <p:nvPr/>
-        </p:nvSpPr>
-        <p:spPr>
-          <a:xfrm>
-            <a:off x="4246778" y="1481328"/>
-            <a:ext cx="1849069" cy="237744"/>
-          </a:xfrm>
-          <a:prstGeom prst="rect">
-            <a:avLst/>
-          </a:prstGeom>
-          <a:noFill/>
-          <a:ln/>
-        </p:spPr>
-        <p:txBody>
-          <a:bodyPr wrap="square" lIns="0" tIns="0" rIns="0" bIns="0" rtlCol="0" anchor="t"/>
-          <a:lstStyle/>
-          <a:p>
-            <a:pPr marL="0" indent="0" algn="ctr">
-              <a:buNone/>
-            </a:pPr>
-            <a:r>
-              <a:rPr lang="en-US" sz="1000" b="1" dirty="0">
-                <a:solidFill>
-                  <a:srgbClr val="5E6978"/>
-                </a:solidFill>
-                <a:latin typeface="Calibri" pitchFamily="34" charset="0"/>
-                <a:ea typeface="Calibri" pitchFamily="34" charset="-122"/>
-                <a:cs typeface="Calibri" pitchFamily="34" charset="-120"/>
-              </a:rPr>
-              <a:t>W3</a:t>
-            </a:r>
-            <a:endParaRPr lang="en-US" sz="1000" dirty="0"/>
-          </a:p>
-        </p:txBody>
-      </p:sp>
-      <p:sp>
-        <p:nvSpPr>
-          <p:cNvPr id="8" name="Text 5"/>
-          <p:cNvSpPr txBox="1"/>
-          <p:nvPr/>
-        </p:nvSpPr>
-        <p:spPr>
-          <a:xfrm>
-            <a:off x="6095848" y="1481328"/>
-            <a:ext cx="1849069" cy="237744"/>
-          </a:xfrm>
-          <a:prstGeom prst="rect">
-            <a:avLst/>
-          </a:prstGeom>
-          <a:noFill/>
-          <a:ln/>
-        </p:spPr>
-        <p:txBody>
-          <a:bodyPr wrap="square" lIns="0" tIns="0" rIns="0" bIns="0" rtlCol="0" anchor="t"/>
-          <a:lstStyle/>
-          <a:p>
-            <a:pPr marL="0" indent="0" algn="ctr">
-              <a:buNone/>
-            </a:pPr>
-            <a:r>
-              <a:rPr lang="en-US" sz="1000" b="1" dirty="0">
-                <a:solidFill>
-                  <a:srgbClr val="5E6978"/>
-                </a:solidFill>
-                <a:latin typeface="Calibri" pitchFamily="34" charset="0"/>
-                <a:ea typeface="Calibri" pitchFamily="34" charset="-122"/>
-                <a:cs typeface="Calibri" pitchFamily="34" charset="-120"/>
-              </a:rPr>
-              <a:t>W4</a:t>
-            </a:r>
-            <a:endParaRPr lang="en-US" sz="1000" dirty="0"/>
-          </a:p>
-        </p:txBody>
-      </p:sp>
-      <p:sp>
-        <p:nvSpPr>
-          <p:cNvPr id="9" name="Text 6"/>
-          <p:cNvSpPr txBox="1"/>
-          <p:nvPr/>
-        </p:nvSpPr>
-        <p:spPr>
-          <a:xfrm>
-            <a:off x="7944917" y="1481328"/>
-            <a:ext cx="1849069" cy="237744"/>
-          </a:xfrm>
-          <a:prstGeom prst="rect">
-            <a:avLst/>
-          </a:prstGeom>
-          <a:noFill/>
-          <a:ln/>
-        </p:spPr>
-        <p:txBody>
-          <a:bodyPr wrap="square" lIns="0" tIns="0" rIns="0" bIns="0" rtlCol="0" anchor="t"/>
-          <a:lstStyle/>
-          <a:p>
-            <a:pPr marL="0" indent="0" algn="ctr">
-              <a:buNone/>
-            </a:pPr>
-            <a:r>
-              <a:rPr lang="en-US" sz="1000" b="1" dirty="0">
-                <a:solidFill>
-                  <a:srgbClr val="5E6978"/>
-                </a:solidFill>
-                <a:latin typeface="Calibri" pitchFamily="34" charset="0"/>
-                <a:ea typeface="Calibri" pitchFamily="34" charset="-122"/>
-                <a:cs typeface="Calibri" pitchFamily="34" charset="-120"/>
-              </a:rPr>
-              <a:t>W5</a:t>
-            </a:r>
-            <a:endParaRPr lang="en-US" sz="1000" dirty="0"/>
-          </a:p>
-        </p:txBody>
-      </p:sp>
-      <p:sp>
-        <p:nvSpPr>
-          <p:cNvPr id="10" name="Text 7"/>
-          <p:cNvSpPr txBox="1"/>
-          <p:nvPr/>
-        </p:nvSpPr>
-        <p:spPr>
-          <a:xfrm>
-            <a:off x="9793986" y="1481328"/>
-            <a:ext cx="1849069" cy="237744"/>
-          </a:xfrm>
-          <a:prstGeom prst="rect">
-            <a:avLst/>
-          </a:prstGeom>
-          <a:noFill/>
-          <a:ln/>
-        </p:spPr>
-        <p:txBody>
-          <a:bodyPr wrap="square" lIns="0" tIns="0" rIns="0" bIns="0" rtlCol="0" anchor="t"/>
-          <a:lstStyle/>
-          <a:p>
-            <a:pPr marL="0" indent="0" algn="ctr">
-              <a:buNone/>
-            </a:pPr>
-            <a:r>
-              <a:rPr lang="en-US" sz="1000" b="1" dirty="0">
-                <a:solidFill>
-                  <a:srgbClr val="5E6978"/>
-                </a:solidFill>
-                <a:latin typeface="Calibri" pitchFamily="34" charset="0"/>
-                <a:ea typeface="Calibri" pitchFamily="34" charset="-122"/>
-                <a:cs typeface="Calibri" pitchFamily="34" charset="-120"/>
-              </a:rPr>
-              <a:t>W6 +</a:t>
-            </a:r>
-            <a:endParaRPr lang="en-US" sz="1000" dirty="0"/>
-          </a:p>
-        </p:txBody>
-      </p:sp>
-      <p:sp>
-        <p:nvSpPr>
-          <p:cNvPr id="11" name="Shape 8"/>
-          <p:cNvSpPr/>
-          <p:nvPr/>
-        </p:nvSpPr>
-        <p:spPr>
-          <a:xfrm>
-            <a:off x="576072" y="1783080"/>
-            <a:ext cx="1794205" cy="310896"/>
-          </a:xfrm>
-          <a:prstGeom prst="roundRect">
-            <a:avLst>
-              <a:gd name="adj" fmla="val 17647"/>
-            </a:avLst>
-          </a:prstGeom>
-          <a:solidFill>
-            <a:srgbClr val="F4A3A7"/>
-          </a:solidFill>
-          <a:ln w="12700">
-            <a:solidFill>
-              <a:srgbClr val="F4A3A7"/>
-            </a:solidFill>
-            <a:prstDash val="solid"/>
-          </a:ln>
-        </p:spPr>
-      </p:sp>
-      <p:sp>
-        <p:nvSpPr>
-          <p:cNvPr id="12" name="Text 9"/>
-          <p:cNvSpPr txBox="1"/>
-          <p:nvPr/>
-        </p:nvSpPr>
-        <p:spPr>
-          <a:xfrm>
-            <a:off x="548640" y="1783080"/>
-            <a:ext cx="1849069" cy="310896"/>
-          </a:xfrm>
-          <a:prstGeom prst="rect">
-            <a:avLst/>
-          </a:prstGeom>
-          <a:noFill/>
-          <a:ln/>
-        </p:spPr>
-        <p:txBody>
-          <a:bodyPr wrap="square" lIns="0" tIns="0" rIns="0" bIns="0" rtlCol="0" anchor="ctr"/>
-          <a:lstStyle/>
-          <a:p>
-            <a:pPr marL="0" indent="0" algn="ctr">
-              <a:buNone/>
-            </a:pPr>
-            <a:r>
-              <a:rPr lang="en-US" sz="1000" b="1" dirty="0">
-                <a:solidFill>
-                  <a:srgbClr val="B0141C"/>
-                </a:solidFill>
-                <a:latin typeface="Calibri" pitchFamily="34" charset="0"/>
-                <a:ea typeface="Calibri" pitchFamily="34" charset="-122"/>
-                <a:cs typeface="Calibri" pitchFamily="34" charset="-120"/>
-              </a:rPr>
-              <a:t>Phase 1</a:t>
-            </a:r>
-            <a:endParaRPr lang="en-US" sz="1000" dirty="0"/>
-          </a:p>
-        </p:txBody>
-      </p:sp>
-      <p:sp>
-        <p:nvSpPr>
-          <p:cNvPr id="13" name="Shape 10"/>
-          <p:cNvSpPr/>
-          <p:nvPr/>
-        </p:nvSpPr>
-        <p:spPr>
-          <a:xfrm>
-            <a:off x="2425141" y="1783080"/>
-            <a:ext cx="1794205" cy="310896"/>
-          </a:xfrm>
-          <a:prstGeom prst="roundRect">
-            <a:avLst>
-              <a:gd name="adj" fmla="val 17647"/>
-            </a:avLst>
-          </a:prstGeom>
-          <a:solidFill>
-            <a:srgbClr val="EC6B71"/>
-          </a:solidFill>
-          <a:ln w="12700">
-            <a:solidFill>
-              <a:srgbClr val="EC6B71"/>
-            </a:solidFill>
-            <a:prstDash val="solid"/>
-          </a:ln>
-        </p:spPr>
-      </p:sp>
-      <p:sp>
-        <p:nvSpPr>
-          <p:cNvPr id="14" name="Text 11"/>
-          <p:cNvSpPr txBox="1"/>
-          <p:nvPr/>
-        </p:nvSpPr>
-        <p:spPr>
-          <a:xfrm>
-            <a:off x="2397709" y="1783080"/>
-            <a:ext cx="1849069" cy="310896"/>
-          </a:xfrm>
-          <a:prstGeom prst="rect">
-            <a:avLst/>
-          </a:prstGeom>
-          <a:noFill/>
-          <a:ln/>
-        </p:spPr>
-        <p:txBody>
-          <a:bodyPr wrap="square" lIns="0" tIns="0" rIns="0" bIns="0" rtlCol="0" anchor="ctr"/>
-          <a:lstStyle/>
-          <a:p>
-            <a:pPr marL="0" indent="0" algn="ctr">
-              <a:buNone/>
-            </a:pPr>
-            <a:r>
-              <a:rPr lang="en-US" sz="1000" b="1" dirty="0">
-                <a:solidFill>
-                  <a:srgbClr val="FFFFFF"/>
-                </a:solidFill>
-                <a:latin typeface="Calibri" pitchFamily="34" charset="0"/>
-                <a:ea typeface="Calibri" pitchFamily="34" charset="-122"/>
-                <a:cs typeface="Calibri" pitchFamily="34" charset="-120"/>
-              </a:rPr>
-              <a:t>Phase 2</a:t>
-            </a:r>
-            <a:endParaRPr lang="en-US" sz="1000" dirty="0"/>
-          </a:p>
-        </p:txBody>
-      </p:sp>
-      <p:sp>
-        <p:nvSpPr>
-          <p:cNvPr id="15" name="Shape 12"/>
-          <p:cNvSpPr/>
-          <p:nvPr/>
-        </p:nvSpPr>
-        <p:spPr>
-          <a:xfrm>
-            <a:off x="4274210" y="1783080"/>
-            <a:ext cx="3643274" cy="310896"/>
-          </a:xfrm>
-          <a:prstGeom prst="roundRect">
-            <a:avLst>
-              <a:gd name="adj" fmla="val 17647"/>
-            </a:avLst>
-          </a:prstGeom>
-          <a:solidFill>
-            <a:srgbClr val="E3202A"/>
-          </a:solidFill>
-          <a:ln w="12700">
-            <a:solidFill>
-              <a:srgbClr val="E3202A"/>
-            </a:solidFill>
-            <a:prstDash val="solid"/>
-          </a:ln>
-        </p:spPr>
-      </p:sp>
-      <p:sp>
-        <p:nvSpPr>
-          <p:cNvPr id="16" name="Text 13"/>
-          <p:cNvSpPr txBox="1"/>
-          <p:nvPr/>
-        </p:nvSpPr>
-        <p:spPr>
-          <a:xfrm>
-            <a:off x="4246778" y="1783080"/>
-            <a:ext cx="3698138" cy="310896"/>
-          </a:xfrm>
-          <a:prstGeom prst="rect">
-            <a:avLst/>
-          </a:prstGeom>
-          <a:noFill/>
-          <a:ln/>
-        </p:spPr>
-        <p:txBody>
-          <a:bodyPr wrap="square" lIns="0" tIns="0" rIns="0" bIns="0" rtlCol="0" anchor="ctr"/>
-          <a:lstStyle/>
-          <a:p>
-            <a:pPr marL="0" indent="0" algn="ctr">
-              <a:buNone/>
-            </a:pPr>
-            <a:r>
-              <a:rPr lang="en-US" sz="1000" b="1" dirty="0">
-                <a:solidFill>
-                  <a:srgbClr val="FFFFFF"/>
-                </a:solidFill>
-                <a:latin typeface="Calibri" pitchFamily="34" charset="0"/>
-                <a:ea typeface="Calibri" pitchFamily="34" charset="-122"/>
-                <a:cs typeface="Calibri" pitchFamily="34" charset="-120"/>
-              </a:rPr>
-              <a:t>Phase 3</a:t>
-            </a:r>
-            <a:endParaRPr lang="en-US" sz="1000" dirty="0"/>
-          </a:p>
-        </p:txBody>
-      </p:sp>
-      <p:sp>
-        <p:nvSpPr>
-          <p:cNvPr id="17" name="Shape 14"/>
-          <p:cNvSpPr/>
-          <p:nvPr/>
-        </p:nvSpPr>
-        <p:spPr>
-          <a:xfrm>
-            <a:off x="7972349" y="1783080"/>
-            <a:ext cx="3643274" cy="310896"/>
-          </a:xfrm>
-          <a:prstGeom prst="roundRect">
-            <a:avLst>
-              <a:gd name="adj" fmla="val 17647"/>
-            </a:avLst>
-          </a:prstGeom>
-          <a:solidFill>
-            <a:srgbClr val="B0141C"/>
-          </a:solidFill>
-          <a:ln w="12700">
-            <a:solidFill>
-              <a:srgbClr val="B0141C"/>
-            </a:solidFill>
-            <a:prstDash val="solid"/>
-          </a:ln>
-        </p:spPr>
-      </p:sp>
-      <p:sp>
-        <p:nvSpPr>
-          <p:cNvPr id="18" name="Text 15"/>
-          <p:cNvSpPr txBox="1"/>
-          <p:nvPr/>
-        </p:nvSpPr>
-        <p:spPr>
-          <a:xfrm>
-            <a:off x="7944917" y="1783080"/>
-            <a:ext cx="3698138" cy="310896"/>
-          </a:xfrm>
-          <a:prstGeom prst="rect">
-            <a:avLst/>
-          </a:prstGeom>
-          <a:noFill/>
-          <a:ln/>
-        </p:spPr>
-        <p:txBody>
-          <a:bodyPr wrap="square" lIns="0" tIns="0" rIns="0" bIns="0" rtlCol="0" anchor="ctr"/>
-          <a:lstStyle/>
-          <a:p>
-            <a:pPr marL="0" indent="0" algn="ctr">
-              <a:buNone/>
-            </a:pPr>
-            <a:r>
-              <a:rPr lang="en-US" sz="1000" b="1" dirty="0">
-                <a:solidFill>
-                  <a:srgbClr val="FFFFFF"/>
-                </a:solidFill>
-                <a:latin typeface="Calibri" pitchFamily="34" charset="0"/>
-                <a:ea typeface="Calibri" pitchFamily="34" charset="-122"/>
-                <a:cs typeface="Calibri" pitchFamily="34" charset="-120"/>
-              </a:rPr>
-              <a:t>Phase 4</a:t>
-            </a:r>
-            <a:endParaRPr lang="en-US" sz="1000" dirty="0"/>
-          </a:p>
-        </p:txBody>
-      </p:sp>
-      <p:sp>
-        <p:nvSpPr>
-          <p:cNvPr id="19" name="Shape 16"/>
-          <p:cNvSpPr/>
-          <p:nvPr/>
-        </p:nvSpPr>
-        <p:spPr>
-          <a:xfrm>
-            <a:off x="548640" y="2331720"/>
-            <a:ext cx="2567864" cy="2944368"/>
-          </a:xfrm>
-          <a:prstGeom prst="roundRect">
-            <a:avLst>
-              <a:gd name="adj" fmla="val 3561"/>
-            </a:avLst>
-          </a:prstGeom>
-          <a:solidFill>
-            <a:srgbClr val="F3F5F8"/>
-          </a:solidFill>
-          <a:ln w="9525">
-            <a:solidFill>
-              <a:srgbClr val="DCE1E7"/>
-            </a:solidFill>
-            <a:prstDash val="solid"/>
-          </a:ln>
-        </p:spPr>
-      </p:sp>
-      <p:sp>
-        <p:nvSpPr>
-          <p:cNvPr id="20" name="Shape 17"/>
-          <p:cNvSpPr/>
-          <p:nvPr/>
-        </p:nvSpPr>
-        <p:spPr>
-          <a:xfrm>
-            <a:off x="822960" y="2587752"/>
-            <a:ext cx="530352" cy="530352"/>
-          </a:xfrm>
-          <a:prstGeom prst="ellipse">
-            <a:avLst/>
-          </a:prstGeom>
-          <a:solidFill>
-            <a:srgbClr val="F4A3A7"/>
-          </a:solidFill>
-          <a:ln w="12700">
-            <a:solidFill>
-              <a:srgbClr val="F4A3A7"/>
-            </a:solidFill>
-            <a:prstDash val="solid"/>
-          </a:ln>
-        </p:spPr>
-      </p:sp>
-      <p:pic>
-        <p:nvPicPr>
-          <p:cNvPr id="21" name="Image 1" descr="preencoded.png"/>
-          <p:cNvPicPr>
-            <a:picLocks noChangeAspect="1"/>
-          </p:cNvPicPr>
-          <p:nvPr/>
-        </p:nvPicPr>
-        <p:blipFill>
-          <a:blip r:embed="rId4"/>
-          <a:stretch>
-            <a:fillRect/>
-          </a:stretch>
-        </p:blipFill>
-        <p:spPr>
-          <a:xfrm>
-            <a:off x="960852" y="2725644"/>
-            <a:ext cx="254569" cy="254569"/>
-          </a:xfrm>
-          <a:prstGeom prst="rect">
-            <a:avLst/>
-          </a:prstGeom>
-        </p:spPr>
-      </p:pic>
-      <p:sp>
-        <p:nvSpPr>
-          <p:cNvPr id="22" name="Text 18"/>
-          <p:cNvSpPr txBox="1"/>
-          <p:nvPr/>
-        </p:nvSpPr>
-        <p:spPr>
-          <a:xfrm>
-            <a:off x="1463040" y="2587752"/>
-            <a:ext cx="1562024" cy="530352"/>
-          </a:xfrm>
-          <a:prstGeom prst="rect">
-            <a:avLst/>
-          </a:prstGeom>
-          <a:noFill/>
-          <a:ln/>
-        </p:spPr>
-        <p:txBody>
-          <a:bodyPr wrap="square" lIns="0" tIns="0" rIns="0" bIns="0" rtlCol="0" anchor="ctr"/>
-          <a:lstStyle/>
-          <a:p>
-            <a:pPr marL="0" indent="0">
-              <a:buNone/>
-            </a:pPr>
-            <a:r>
-              <a:rPr lang="en-US" sz="1000" b="1" kern="0" spc="100" dirty="0">
-                <a:solidFill>
-                  <a:srgbClr val="E3202A"/>
-                </a:solidFill>
-                <a:latin typeface="Calibri" pitchFamily="34" charset="0"/>
-                <a:ea typeface="Calibri" pitchFamily="34" charset="-122"/>
-                <a:cs typeface="Calibri" pitchFamily="34" charset="-120"/>
-              </a:rPr>
-              <a:t>PHASE 1  ·  WEEK 1</a:t>
-            </a:r>
-            <a:endParaRPr lang="en-US" sz="1000" dirty="0"/>
-          </a:p>
-        </p:txBody>
-      </p:sp>
-      <p:sp>
-        <p:nvSpPr>
-          <p:cNvPr id="23" name="Text 19"/>
-          <p:cNvSpPr txBox="1"/>
-          <p:nvPr/>
-        </p:nvSpPr>
-        <p:spPr>
-          <a:xfrm>
-            <a:off x="822960" y="3246120"/>
-            <a:ext cx="2110664" cy="329184"/>
-          </a:xfrm>
-          <a:prstGeom prst="rect">
-            <a:avLst/>
-          </a:prstGeom>
-          <a:noFill/>
-          <a:ln/>
-        </p:spPr>
-        <p:txBody>
-          <a:bodyPr wrap="square" lIns="0" tIns="0" rIns="0" bIns="0" rtlCol="0" anchor="t"/>
-          <a:lstStyle/>
-          <a:p>
-            <a:pPr marL="0" indent="0">
-              <a:buNone/>
-            </a:pPr>
-            <a:r>
-              <a:rPr lang="en-US" sz="1500" b="1" dirty="0">
-                <a:solidFill>
-                  <a:srgbClr val="151A21"/>
-                </a:solidFill>
-                <a:latin typeface="Arial" pitchFamily="34" charset="0"/>
-                <a:ea typeface="Arial" pitchFamily="34" charset="-122"/>
-                <a:cs typeface="Arial" pitchFamily="34" charset="-120"/>
-              </a:rPr>
-              <a:t>Assess &amp; Design</a:t>
-            </a:r>
-            <a:endParaRPr lang="en-US" sz="1500" dirty="0"/>
-          </a:p>
-        </p:txBody>
-      </p:sp>
-      <p:pic>
-        <p:nvPicPr>
-          <p:cNvPr id="24" name="Image 2" descr="preencoded.png"/>
-          <p:cNvPicPr>
-            <a:picLocks noChangeAspect="1"/>
-          </p:cNvPicPr>
-          <p:nvPr/>
-        </p:nvPicPr>
-        <p:blipFill>
-          <a:blip r:embed="rId5"/>
-          <a:stretch>
-            <a:fillRect/>
-          </a:stretch>
-        </p:blipFill>
-        <p:spPr>
-          <a:xfrm>
-            <a:off x="822960" y="3749040"/>
-            <a:ext cx="164592" cy="164592"/>
-          </a:xfrm>
-          <a:prstGeom prst="rect">
-            <a:avLst/>
-          </a:prstGeom>
-        </p:spPr>
-      </p:pic>
-      <p:sp>
-        <p:nvSpPr>
-          <p:cNvPr id="25" name="Text 20"/>
-          <p:cNvSpPr txBox="1"/>
-          <p:nvPr/>
-        </p:nvSpPr>
-        <p:spPr>
-          <a:xfrm>
-            <a:off x="1097280" y="3703320"/>
-            <a:ext cx="1836344" cy="475488"/>
-          </a:xfrm>
-          <a:prstGeom prst="rect">
-            <a:avLst/>
-          </a:prstGeom>
-          <a:noFill/>
-          <a:ln/>
-        </p:spPr>
-        <p:txBody>
-          <a:bodyPr wrap="square" lIns="0" tIns="0" rIns="0" bIns="0" rtlCol="0" anchor="t"/>
-          <a:lstStyle/>
-          <a:p>
-            <a:pPr marL="0" indent="0">
-              <a:buNone/>
-            </a:pPr>
-            <a:r>
-              <a:rPr lang="en-US" sz="1150" dirty="0">
-                <a:solidFill>
-                  <a:srgbClr val="151A21"/>
-                </a:solidFill>
-                <a:latin typeface="Calibri" pitchFamily="34" charset="0"/>
-                <a:ea typeface="Calibri" pitchFamily="34" charset="-122"/>
-                <a:cs typeface="Calibri" pitchFamily="34" charset="-120"/>
-              </a:rPr>
-              <a:t>Endpoint inventory and OS check</a:t>
-            </a:r>
-            <a:endParaRPr lang="en-US" sz="1150" dirty="0"/>
-          </a:p>
-        </p:txBody>
-      </p:sp>
-      <p:pic>
-        <p:nvPicPr>
-          <p:cNvPr id="26" name="Image 3" descr="preencoded.png"/>
-          <p:cNvPicPr>
-            <a:picLocks noChangeAspect="1"/>
-          </p:cNvPicPr>
-          <p:nvPr/>
-        </p:nvPicPr>
-        <p:blipFill>
-          <a:blip r:embed="rId5"/>
-          <a:stretch>
-            <a:fillRect/>
-          </a:stretch>
-        </p:blipFill>
-        <p:spPr>
-          <a:xfrm>
-            <a:off x="822960" y="4261104"/>
-            <a:ext cx="164592" cy="164592"/>
-          </a:xfrm>
-          <a:prstGeom prst="rect">
-            <a:avLst/>
-          </a:prstGeom>
-        </p:spPr>
-      </p:pic>
-      <p:sp>
-        <p:nvSpPr>
-          <p:cNvPr id="27" name="Text 21"/>
-          <p:cNvSpPr txBox="1"/>
-          <p:nvPr/>
-        </p:nvSpPr>
-        <p:spPr>
-          <a:xfrm>
-            <a:off x="1097280" y="4215384"/>
-            <a:ext cx="1836344" cy="475488"/>
-          </a:xfrm>
-          <a:prstGeom prst="rect">
-            <a:avLst/>
-          </a:prstGeom>
-          <a:noFill/>
-          <a:ln/>
-        </p:spPr>
-        <p:txBody>
-          <a:bodyPr wrap="square" lIns="0" tIns="0" rIns="0" bIns="0" rtlCol="0" anchor="t"/>
-          <a:lstStyle/>
-          <a:p>
-            <a:pPr marL="0" indent="0">
-              <a:buNone/>
-            </a:pPr>
-            <a:r>
-              <a:rPr lang="en-US" sz="1150" dirty="0">
-                <a:solidFill>
-                  <a:srgbClr val="151A21"/>
-                </a:solidFill>
-                <a:latin typeface="Calibri" pitchFamily="34" charset="0"/>
-                <a:ea typeface="Calibri" pitchFamily="34" charset="-122"/>
-                <a:cs typeface="Calibri" pitchFamily="34" charset="-120"/>
-              </a:rPr>
-              <a:t>Identify critical systems (PMS, POS, servers)</a:t>
-            </a:r>
-            <a:endParaRPr lang="en-US" sz="1150" dirty="0"/>
-          </a:p>
-        </p:txBody>
-      </p:sp>
-      <p:pic>
-        <p:nvPicPr>
-          <p:cNvPr id="28" name="Image 4" descr="preencoded.png"/>
-          <p:cNvPicPr>
-            <a:picLocks noChangeAspect="1"/>
-          </p:cNvPicPr>
-          <p:nvPr/>
-        </p:nvPicPr>
-        <p:blipFill>
-          <a:blip r:embed="rId5"/>
-          <a:stretch>
-            <a:fillRect/>
-          </a:stretch>
-        </p:blipFill>
-        <p:spPr>
-          <a:xfrm>
-            <a:off x="822960" y="4773168"/>
-            <a:ext cx="164592" cy="164592"/>
-          </a:xfrm>
-          <a:prstGeom prst="rect">
-            <a:avLst/>
-          </a:prstGeom>
-        </p:spPr>
-      </p:pic>
-      <p:sp>
-        <p:nvSpPr>
-          <p:cNvPr id="29" name="Text 22"/>
-          <p:cNvSpPr txBox="1"/>
-          <p:nvPr/>
-        </p:nvSpPr>
-        <p:spPr>
-          <a:xfrm>
-            <a:off x="1097280" y="4727448"/>
-            <a:ext cx="1836344" cy="475488"/>
-          </a:xfrm>
-          <a:prstGeom prst="rect">
-            <a:avLst/>
-          </a:prstGeom>
-          <a:noFill/>
-          <a:ln/>
-        </p:spPr>
-        <p:txBody>
-          <a:bodyPr wrap="square" lIns="0" tIns="0" rIns="0" bIns="0" rtlCol="0" anchor="t"/>
-          <a:lstStyle/>
-          <a:p>
-            <a:pPr marL="0" indent="0">
-              <a:buNone/>
-            </a:pPr>
-            <a:r>
-              <a:rPr lang="en-US" sz="1150" dirty="0">
-                <a:solidFill>
-                  <a:srgbClr val="151A21"/>
-                </a:solidFill>
-                <a:latin typeface="Calibri" pitchFamily="34" charset="0"/>
-                <a:ea typeface="Calibri" pitchFamily="34" charset="-122"/>
-                <a:cs typeface="Calibri" pitchFamily="34" charset="-120"/>
-              </a:rPr>
-              <a:t>Define policies and success criteria</a:t>
-            </a:r>
-            <a:endParaRPr lang="en-US" sz="1150" dirty="0"/>
-          </a:p>
-        </p:txBody>
-      </p:sp>
-      <p:sp>
-        <p:nvSpPr>
-          <p:cNvPr id="30" name="Shape 23"/>
-          <p:cNvSpPr/>
-          <p:nvPr/>
-        </p:nvSpPr>
-        <p:spPr>
-          <a:xfrm>
-            <a:off x="3390824" y="2331720"/>
-            <a:ext cx="2567864" cy="2944368"/>
-          </a:xfrm>
-          <a:prstGeom prst="roundRect">
-            <a:avLst>
-              <a:gd name="adj" fmla="val 3561"/>
-            </a:avLst>
-          </a:prstGeom>
-          <a:solidFill>
-            <a:srgbClr val="F3F5F8"/>
-          </a:solidFill>
-          <a:ln w="9525">
-            <a:solidFill>
-              <a:srgbClr val="DCE1E7"/>
-            </a:solidFill>
-            <a:prstDash val="solid"/>
-          </a:ln>
-        </p:spPr>
-      </p:sp>
-      <p:sp>
-        <p:nvSpPr>
-          <p:cNvPr id="31" name="Shape 24"/>
-          <p:cNvSpPr/>
-          <p:nvPr/>
-        </p:nvSpPr>
-        <p:spPr>
-          <a:xfrm>
-            <a:off x="3665144" y="2587752"/>
-            <a:ext cx="530352" cy="530352"/>
-          </a:xfrm>
-          <a:prstGeom prst="ellipse">
-            <a:avLst/>
-          </a:prstGeom>
-          <a:solidFill>
-            <a:srgbClr val="EC6B71"/>
-          </a:solidFill>
-          <a:ln w="12700">
-            <a:solidFill>
-              <a:srgbClr val="EC6B71"/>
-            </a:solidFill>
-            <a:prstDash val="solid"/>
-          </a:ln>
-        </p:spPr>
-      </p:sp>
-      <p:pic>
-        <p:nvPicPr>
-          <p:cNvPr id="32" name="Image 5" descr="preencoded.png"/>
-          <p:cNvPicPr>
-            <a:picLocks noChangeAspect="1"/>
-          </p:cNvPicPr>
-          <p:nvPr/>
-        </p:nvPicPr>
-        <p:blipFill>
-          <a:blip r:embed="rId6"/>
-          <a:stretch>
-            <a:fillRect/>
-          </a:stretch>
-        </p:blipFill>
-        <p:spPr>
-          <a:xfrm>
-            <a:off x="3803035" y="2725644"/>
-            <a:ext cx="254569" cy="254569"/>
-          </a:xfrm>
-          <a:prstGeom prst="rect">
-            <a:avLst/>
-          </a:prstGeom>
-        </p:spPr>
-      </p:pic>
-      <p:sp>
-        <p:nvSpPr>
-          <p:cNvPr id="33" name="Text 25"/>
-          <p:cNvSpPr txBox="1"/>
-          <p:nvPr/>
-        </p:nvSpPr>
-        <p:spPr>
-          <a:xfrm>
-            <a:off x="4305224" y="2587752"/>
-            <a:ext cx="1562024" cy="530352"/>
-          </a:xfrm>
-          <a:prstGeom prst="rect">
-            <a:avLst/>
-          </a:prstGeom>
-          <a:noFill/>
-          <a:ln/>
-        </p:spPr>
-        <p:txBody>
-          <a:bodyPr wrap="square" lIns="0" tIns="0" rIns="0" bIns="0" rtlCol="0" anchor="ctr"/>
-          <a:lstStyle/>
-          <a:p>
-            <a:pPr marL="0" indent="0">
-              <a:buNone/>
-            </a:pPr>
-            <a:r>
-              <a:rPr lang="en-US" sz="1000" b="1" kern="0" spc="100" dirty="0">
-                <a:solidFill>
-                  <a:srgbClr val="E3202A"/>
-                </a:solidFill>
-                <a:latin typeface="Calibri" pitchFamily="34" charset="0"/>
-                <a:ea typeface="Calibri" pitchFamily="34" charset="-122"/>
-                <a:cs typeface="Calibri" pitchFamily="34" charset="-120"/>
-              </a:rPr>
-              <a:t>PHASE 2  ·  WEEK 2</a:t>
-            </a:r>
-            <a:endParaRPr lang="en-US" sz="1000" dirty="0"/>
-          </a:p>
-        </p:txBody>
-      </p:sp>
-      <p:sp>
-        <p:nvSpPr>
-          <p:cNvPr id="34" name="Text 26"/>
-          <p:cNvSpPr txBox="1"/>
-          <p:nvPr/>
-        </p:nvSpPr>
-        <p:spPr>
-          <a:xfrm>
-            <a:off x="3665144" y="3246120"/>
-            <a:ext cx="2110664" cy="329184"/>
-          </a:xfrm>
-          <a:prstGeom prst="rect">
-            <a:avLst/>
-          </a:prstGeom>
-          <a:noFill/>
-          <a:ln/>
-        </p:spPr>
-        <p:txBody>
-          <a:bodyPr wrap="square" lIns="0" tIns="0" rIns="0" bIns="0" rtlCol="0" anchor="t"/>
-          <a:lstStyle/>
-          <a:p>
-            <a:pPr marL="0" indent="0">
-              <a:buNone/>
-            </a:pPr>
-            <a:r>
-              <a:rPr lang="en-US" sz="1500" b="1" dirty="0">
-                <a:solidFill>
-                  <a:srgbClr val="151A21"/>
-                </a:solidFill>
-                <a:latin typeface="Arial" pitchFamily="34" charset="0"/>
-                <a:ea typeface="Arial" pitchFamily="34" charset="-122"/>
-                <a:cs typeface="Arial" pitchFamily="34" charset="-120"/>
-              </a:rPr>
-              <a:t>Pilot</a:t>
-            </a:r>
-            <a:endParaRPr lang="en-US" sz="1500" dirty="0"/>
-          </a:p>
-        </p:txBody>
-      </p:sp>
-      <p:pic>
-        <p:nvPicPr>
-          <p:cNvPr id="35" name="Image 6" descr="preencoded.png"/>
-          <p:cNvPicPr>
-            <a:picLocks noChangeAspect="1"/>
-          </p:cNvPicPr>
-          <p:nvPr/>
-        </p:nvPicPr>
-        <p:blipFill>
-          <a:blip r:embed="rId5"/>
-          <a:stretch>
-            <a:fillRect/>
-          </a:stretch>
-        </p:blipFill>
-        <p:spPr>
-          <a:xfrm>
-            <a:off x="3665144" y="3749040"/>
-            <a:ext cx="164592" cy="164592"/>
-          </a:xfrm>
-          <a:prstGeom prst="rect">
-            <a:avLst/>
-          </a:prstGeom>
-        </p:spPr>
-      </p:pic>
-      <p:sp>
-        <p:nvSpPr>
-          <p:cNvPr id="36" name="Text 27"/>
-          <p:cNvSpPr txBox="1"/>
-          <p:nvPr/>
-        </p:nvSpPr>
-        <p:spPr>
-          <a:xfrm>
-            <a:off x="3939464" y="3703320"/>
-            <a:ext cx="1836344" cy="475488"/>
-          </a:xfrm>
-          <a:prstGeom prst="rect">
-            <a:avLst/>
-          </a:prstGeom>
-          <a:noFill/>
-          <a:ln/>
-        </p:spPr>
-        <p:txBody>
-          <a:bodyPr wrap="square" lIns="0" tIns="0" rIns="0" bIns="0" rtlCol="0" anchor="t"/>
-          <a:lstStyle/>
-          <a:p>
-            <a:pPr marL="0" indent="0">
-              <a:buNone/>
-            </a:pPr>
-            <a:r>
-              <a:rPr lang="en-US" sz="1150" dirty="0">
-                <a:solidFill>
-                  <a:srgbClr val="151A21"/>
-                </a:solidFill>
-                <a:latin typeface="Calibri" pitchFamily="34" charset="0"/>
-                <a:ea typeface="Calibri" pitchFamily="34" charset="-122"/>
-                <a:cs typeface="Calibri" pitchFamily="34" charset="-120"/>
-              </a:rPr>
-              <a:t>Install sensor on a pilot group</a:t>
-            </a:r>
-            <a:endParaRPr lang="en-US" sz="1150" dirty="0"/>
-          </a:p>
-        </p:txBody>
-      </p:sp>
-      <p:pic>
-        <p:nvPicPr>
-          <p:cNvPr id="37" name="Image 7" descr="preencoded.png"/>
-          <p:cNvPicPr>
-            <a:picLocks noChangeAspect="1"/>
-          </p:cNvPicPr>
-          <p:nvPr/>
-        </p:nvPicPr>
-        <p:blipFill>
-          <a:blip r:embed="rId5"/>
-          <a:stretch>
-            <a:fillRect/>
-          </a:stretch>
-        </p:blipFill>
-        <p:spPr>
-          <a:xfrm>
-            <a:off x="3665144" y="4261104"/>
-            <a:ext cx="164592" cy="164592"/>
-          </a:xfrm>
-          <a:prstGeom prst="rect">
-            <a:avLst/>
-          </a:prstGeom>
-        </p:spPr>
-      </p:pic>
-      <p:sp>
-        <p:nvSpPr>
-          <p:cNvPr id="38" name="Text 28"/>
-          <p:cNvSpPr txBox="1"/>
-          <p:nvPr/>
-        </p:nvSpPr>
-        <p:spPr>
-          <a:xfrm>
-            <a:off x="3939464" y="4215384"/>
-            <a:ext cx="1836344" cy="475488"/>
-          </a:xfrm>
-          <a:prstGeom prst="rect">
-            <a:avLst/>
-          </a:prstGeom>
-          <a:noFill/>
-          <a:ln/>
-        </p:spPr>
-        <p:txBody>
-          <a:bodyPr wrap="square" lIns="0" tIns="0" rIns="0" bIns="0" rtlCol="0" anchor="t"/>
-          <a:lstStyle/>
-          <a:p>
-            <a:pPr marL="0" indent="0">
-              <a:buNone/>
-            </a:pPr>
-            <a:r>
-              <a:rPr lang="en-US" sz="1150" dirty="0">
-                <a:solidFill>
-                  <a:srgbClr val="151A21"/>
-                </a:solidFill>
-                <a:latin typeface="Calibri" pitchFamily="34" charset="0"/>
-                <a:ea typeface="Calibri" pitchFamily="34" charset="-122"/>
-                <a:cs typeface="Calibri" pitchFamily="34" charset="-120"/>
-              </a:rPr>
-              <a:t>Run in detect-only mode first</a:t>
-            </a:r>
-            <a:endParaRPr lang="en-US" sz="1150" dirty="0"/>
-          </a:p>
-        </p:txBody>
-      </p:sp>
-      <p:pic>
-        <p:nvPicPr>
-          <p:cNvPr id="39" name="Image 8" descr="preencoded.png"/>
-          <p:cNvPicPr>
-            <a:picLocks noChangeAspect="1"/>
-          </p:cNvPicPr>
-          <p:nvPr/>
-        </p:nvPicPr>
-        <p:blipFill>
-          <a:blip r:embed="rId5"/>
-          <a:stretch>
-            <a:fillRect/>
-          </a:stretch>
-        </p:blipFill>
-        <p:spPr>
-          <a:xfrm>
-            <a:off x="3665144" y="4773168"/>
-            <a:ext cx="164592" cy="164592"/>
-          </a:xfrm>
-          <a:prstGeom prst="rect">
-            <a:avLst/>
-          </a:prstGeom>
-        </p:spPr>
-      </p:pic>
-      <p:sp>
-        <p:nvSpPr>
-          <p:cNvPr id="40" name="Text 29"/>
-          <p:cNvSpPr txBox="1"/>
-          <p:nvPr/>
-        </p:nvSpPr>
-        <p:spPr>
-          <a:xfrm>
-            <a:off x="3939464" y="4727448"/>
-            <a:ext cx="1836344" cy="475488"/>
-          </a:xfrm>
-          <a:prstGeom prst="rect">
-            <a:avLst/>
-          </a:prstGeom>
-          <a:noFill/>
-          <a:ln/>
-        </p:spPr>
-        <p:txBody>
-          <a:bodyPr wrap="square" lIns="0" tIns="0" rIns="0" bIns="0" rtlCol="0" anchor="t"/>
-          <a:lstStyle/>
-          <a:p>
-            <a:pPr marL="0" indent="0">
-              <a:buNone/>
-            </a:pPr>
-            <a:r>
-              <a:rPr lang="en-US" sz="1150" dirty="0">
-                <a:solidFill>
-                  <a:srgbClr val="151A21"/>
-                </a:solidFill>
-                <a:latin typeface="Calibri" pitchFamily="34" charset="0"/>
-                <a:ea typeface="Calibri" pitchFamily="34" charset="-122"/>
-                <a:cs typeface="Calibri" pitchFamily="34" charset="-120"/>
-              </a:rPr>
-              <a:t>Confirm compatibility with hotel applications</a:t>
-            </a:r>
-            <a:endParaRPr lang="en-US" sz="1150" dirty="0"/>
-          </a:p>
-        </p:txBody>
-      </p:sp>
-      <p:sp>
-        <p:nvSpPr>
-          <p:cNvPr id="41" name="Shape 30"/>
-          <p:cNvSpPr/>
-          <p:nvPr/>
-        </p:nvSpPr>
-        <p:spPr>
-          <a:xfrm>
-            <a:off x="6233008" y="2331720"/>
-            <a:ext cx="2567864" cy="2944368"/>
-          </a:xfrm>
-          <a:prstGeom prst="roundRect">
-            <a:avLst>
-              <a:gd name="adj" fmla="val 3561"/>
-            </a:avLst>
-          </a:prstGeom>
-          <a:solidFill>
-            <a:srgbClr val="F3F5F8"/>
-          </a:solidFill>
-          <a:ln w="9525">
-            <a:solidFill>
-              <a:srgbClr val="DCE1E7"/>
-            </a:solidFill>
-            <a:prstDash val="solid"/>
-          </a:ln>
-        </p:spPr>
-      </p:sp>
-      <p:sp>
-        <p:nvSpPr>
-          <p:cNvPr id="42" name="Shape 31"/>
-          <p:cNvSpPr/>
-          <p:nvPr/>
-        </p:nvSpPr>
-        <p:spPr>
-          <a:xfrm>
-            <a:off x="6507328" y="2587752"/>
-            <a:ext cx="530352" cy="530352"/>
-          </a:xfrm>
-          <a:prstGeom prst="ellipse">
-            <a:avLst/>
-          </a:prstGeom>
-          <a:solidFill>
-            <a:srgbClr val="E3202A"/>
-          </a:solidFill>
-          <a:ln w="12700">
-            <a:solidFill>
-              <a:srgbClr val="E3202A"/>
-            </a:solidFill>
-            <a:prstDash val="solid"/>
-          </a:ln>
-        </p:spPr>
-      </p:sp>
-      <p:pic>
-        <p:nvPicPr>
-          <p:cNvPr id="43" name="Image 9" descr="preencoded.png"/>
-          <p:cNvPicPr>
-            <a:picLocks noChangeAspect="1"/>
-          </p:cNvPicPr>
-          <p:nvPr/>
-        </p:nvPicPr>
-        <p:blipFill>
-          <a:blip r:embed="rId7"/>
-          <a:stretch>
-            <a:fillRect/>
-          </a:stretch>
-        </p:blipFill>
-        <p:spPr>
-          <a:xfrm>
-            <a:off x="6645219" y="2725644"/>
-            <a:ext cx="254569" cy="254569"/>
-          </a:xfrm>
-          <a:prstGeom prst="rect">
-            <a:avLst/>
-          </a:prstGeom>
-        </p:spPr>
-      </p:pic>
-      <p:sp>
-        <p:nvSpPr>
-          <p:cNvPr id="44" name="Text 32"/>
-          <p:cNvSpPr txBox="1"/>
-          <p:nvPr/>
-        </p:nvSpPr>
-        <p:spPr>
-          <a:xfrm>
-            <a:off x="7147408" y="2587752"/>
-            <a:ext cx="1562024" cy="530352"/>
-          </a:xfrm>
-          <a:prstGeom prst="rect">
-            <a:avLst/>
-          </a:prstGeom>
-          <a:noFill/>
-          <a:ln/>
-        </p:spPr>
-        <p:txBody>
-          <a:bodyPr wrap="square" lIns="0" tIns="0" rIns="0" bIns="0" rtlCol="0" anchor="ctr"/>
-          <a:lstStyle/>
-          <a:p>
-            <a:pPr marL="0" indent="0">
-              <a:buNone/>
-            </a:pPr>
-            <a:r>
-              <a:rPr lang="en-US" sz="1000" b="1" kern="0" spc="100" dirty="0">
-                <a:solidFill>
-                  <a:srgbClr val="E3202A"/>
-                </a:solidFill>
-                <a:latin typeface="Calibri" pitchFamily="34" charset="0"/>
-                <a:ea typeface="Calibri" pitchFamily="34" charset="-122"/>
-                <a:cs typeface="Calibri" pitchFamily="34" charset="-120"/>
-              </a:rPr>
-              <a:t>PHASE 3  ·  WEEKS 3–4</a:t>
-            </a:r>
-            <a:endParaRPr lang="en-US" sz="1000" dirty="0"/>
-          </a:p>
-        </p:txBody>
-      </p:sp>
-      <p:sp>
-        <p:nvSpPr>
-          <p:cNvPr id="45" name="Text 33"/>
-          <p:cNvSpPr txBox="1"/>
-          <p:nvPr/>
-        </p:nvSpPr>
-        <p:spPr>
-          <a:xfrm>
-            <a:off x="6507328" y="3246120"/>
-            <a:ext cx="2110664" cy="329184"/>
-          </a:xfrm>
-          <a:prstGeom prst="rect">
-            <a:avLst/>
-          </a:prstGeom>
-          <a:noFill/>
-          <a:ln/>
-        </p:spPr>
-        <p:txBody>
-          <a:bodyPr wrap="square" lIns="0" tIns="0" rIns="0" bIns="0" rtlCol="0" anchor="t"/>
-          <a:lstStyle/>
-          <a:p>
-            <a:pPr marL="0" indent="0">
-              <a:buNone/>
-            </a:pPr>
-            <a:r>
-              <a:rPr lang="en-US" sz="1500" b="1" dirty="0">
-                <a:solidFill>
-                  <a:srgbClr val="151A21"/>
-                </a:solidFill>
-                <a:latin typeface="Arial" pitchFamily="34" charset="0"/>
-                <a:ea typeface="Arial" pitchFamily="34" charset="-122"/>
-                <a:cs typeface="Arial" pitchFamily="34" charset="-120"/>
-              </a:rPr>
-              <a:t>Full Rollout</a:t>
-            </a:r>
-            <a:endParaRPr lang="en-US" sz="1500" dirty="0"/>
-          </a:p>
-        </p:txBody>
-      </p:sp>
-      <p:pic>
-        <p:nvPicPr>
-          <p:cNvPr id="46" name="Image 10" descr="preencoded.png"/>
-          <p:cNvPicPr>
-            <a:picLocks noChangeAspect="1"/>
-          </p:cNvPicPr>
-          <p:nvPr/>
-        </p:nvPicPr>
-        <p:blipFill>
-          <a:blip r:embed="rId5"/>
-          <a:stretch>
-            <a:fillRect/>
-          </a:stretch>
-        </p:blipFill>
-        <p:spPr>
-          <a:xfrm>
-            <a:off x="6507328" y="3749040"/>
-            <a:ext cx="164592" cy="164592"/>
-          </a:xfrm>
-          <a:prstGeom prst="rect">
-            <a:avLst/>
-          </a:prstGeom>
-        </p:spPr>
-      </p:pic>
-      <p:sp>
-        <p:nvSpPr>
-          <p:cNvPr id="47" name="Text 34"/>
-          <p:cNvSpPr txBox="1"/>
-          <p:nvPr/>
-        </p:nvSpPr>
-        <p:spPr>
-          <a:xfrm>
-            <a:off x="6781648" y="3703320"/>
-            <a:ext cx="1836344" cy="475488"/>
-          </a:xfrm>
-          <a:prstGeom prst="rect">
-            <a:avLst/>
-          </a:prstGeom>
-          <a:noFill/>
-          <a:ln/>
-        </p:spPr>
-        <p:txBody>
-          <a:bodyPr wrap="square" lIns="0" tIns="0" rIns="0" bIns="0" rtlCol="0" anchor="t"/>
-          <a:lstStyle/>
-          <a:p>
-            <a:pPr marL="0" indent="0">
-              <a:buNone/>
-            </a:pPr>
-            <a:r>
-              <a:rPr lang="en-US" sz="1150" dirty="0">
-                <a:solidFill>
-                  <a:srgbClr val="151A21"/>
-                </a:solidFill>
-                <a:latin typeface="Calibri" pitchFamily="34" charset="0"/>
-                <a:ea typeface="Calibri" pitchFamily="34" charset="-122"/>
-                <a:cs typeface="Calibri" pitchFamily="34" charset="-120"/>
-              </a:rPr>
-              <a:t>Department-by-department rollout</a:t>
-            </a:r>
-            <a:endParaRPr lang="en-US" sz="1150" dirty="0"/>
-          </a:p>
-        </p:txBody>
-      </p:sp>
-      <p:pic>
-        <p:nvPicPr>
-          <p:cNvPr id="48" name="Image 11" descr="preencoded.png"/>
-          <p:cNvPicPr>
-            <a:picLocks noChangeAspect="1"/>
-          </p:cNvPicPr>
-          <p:nvPr/>
-        </p:nvPicPr>
-        <p:blipFill>
-          <a:blip r:embed="rId5"/>
-          <a:stretch>
-            <a:fillRect/>
-          </a:stretch>
-        </p:blipFill>
-        <p:spPr>
-          <a:xfrm>
-            <a:off x="6507328" y="4261104"/>
-            <a:ext cx="164592" cy="164592"/>
-          </a:xfrm>
-          <a:prstGeom prst="rect">
-            <a:avLst/>
-          </a:prstGeom>
-        </p:spPr>
-      </p:pic>
-      <p:sp>
-        <p:nvSpPr>
-          <p:cNvPr id="49" name="Text 35"/>
-          <p:cNvSpPr txBox="1"/>
-          <p:nvPr/>
-        </p:nvSpPr>
-        <p:spPr>
-          <a:xfrm>
-            <a:off x="6781648" y="4215384"/>
-            <a:ext cx="1836344" cy="475488"/>
-          </a:xfrm>
-          <a:prstGeom prst="rect">
-            <a:avLst/>
-          </a:prstGeom>
-          <a:noFill/>
-          <a:ln/>
-        </p:spPr>
-        <p:txBody>
-          <a:bodyPr wrap="square" lIns="0" tIns="0" rIns="0" bIns="0" rtlCol="0" anchor="t"/>
-          <a:lstStyle/>
-          <a:p>
-            <a:pPr marL="0" indent="0">
-              <a:buNone/>
-            </a:pPr>
-            <a:r>
-              <a:rPr lang="en-US" sz="1150" dirty="0">
-                <a:solidFill>
-                  <a:srgbClr val="151A21"/>
-                </a:solidFill>
-                <a:latin typeface="Calibri" pitchFamily="34" charset="0"/>
-                <a:ea typeface="Calibri" pitchFamily="34" charset="-122"/>
-                <a:cs typeface="Calibri" pitchFamily="34" charset="-120"/>
-              </a:rPr>
-              <a:t>Switch on prevention policies</a:t>
-            </a:r>
-            <a:endParaRPr lang="en-US" sz="1150" dirty="0"/>
-          </a:p>
-        </p:txBody>
-      </p:sp>
-      <p:pic>
-        <p:nvPicPr>
-          <p:cNvPr id="50" name="Image 12" descr="preencoded.png"/>
-          <p:cNvPicPr>
-            <a:picLocks noChangeAspect="1"/>
-          </p:cNvPicPr>
-          <p:nvPr/>
-        </p:nvPicPr>
-        <p:blipFill>
-          <a:blip r:embed="rId5"/>
-          <a:stretch>
-            <a:fillRect/>
-          </a:stretch>
-        </p:blipFill>
-        <p:spPr>
-          <a:xfrm>
-            <a:off x="6507328" y="4773168"/>
-            <a:ext cx="164592" cy="164592"/>
-          </a:xfrm>
-          <a:prstGeom prst="rect">
-            <a:avLst/>
-          </a:prstGeom>
-        </p:spPr>
-      </p:pic>
-      <p:sp>
-        <p:nvSpPr>
-          <p:cNvPr id="51" name="Text 36"/>
-          <p:cNvSpPr txBox="1"/>
-          <p:nvPr/>
-        </p:nvSpPr>
-        <p:spPr>
-          <a:xfrm>
-            <a:off x="6781648" y="4727448"/>
-            <a:ext cx="1836344" cy="475488"/>
-          </a:xfrm>
-          <a:prstGeom prst="rect">
-            <a:avLst/>
-          </a:prstGeom>
-          <a:noFill/>
-          <a:ln/>
-        </p:spPr>
-        <p:txBody>
-          <a:bodyPr wrap="square" lIns="0" tIns="0" rIns="0" bIns="0" rtlCol="0" anchor="t"/>
-          <a:lstStyle/>
-          <a:p>
-            <a:pPr marL="0" indent="0">
-              <a:buNone/>
-            </a:pPr>
-            <a:r>
-              <a:rPr lang="en-US" sz="1150" dirty="0">
-                <a:solidFill>
-                  <a:srgbClr val="151A21"/>
-                </a:solidFill>
-                <a:latin typeface="Calibri" pitchFamily="34" charset="0"/>
-                <a:ea typeface="Calibri" pitchFamily="34" charset="-122"/>
-                <a:cs typeface="Calibri" pitchFamily="34" charset="-120"/>
-              </a:rPr>
-              <a:t>Staged sensor updates — pilot group first</a:t>
-            </a:r>
-            <a:endParaRPr lang="en-US" sz="1150" dirty="0"/>
-          </a:p>
-        </p:txBody>
-      </p:sp>
-      <p:sp>
-        <p:nvSpPr>
-          <p:cNvPr id="52" name="Shape 37"/>
-          <p:cNvSpPr/>
-          <p:nvPr/>
-        </p:nvSpPr>
-        <p:spPr>
-          <a:xfrm>
-            <a:off x="9075191" y="2331720"/>
-            <a:ext cx="2567864" cy="2944368"/>
-          </a:xfrm>
-          <a:prstGeom prst="roundRect">
-            <a:avLst>
-              <a:gd name="adj" fmla="val 3561"/>
-            </a:avLst>
-          </a:prstGeom>
-          <a:solidFill>
-            <a:srgbClr val="F3F5F8"/>
-          </a:solidFill>
-          <a:ln w="9525">
-            <a:solidFill>
-              <a:srgbClr val="DCE1E7"/>
-            </a:solidFill>
-            <a:prstDash val="solid"/>
-          </a:ln>
-        </p:spPr>
-      </p:sp>
-      <p:sp>
-        <p:nvSpPr>
-          <p:cNvPr id="53" name="Shape 38"/>
-          <p:cNvSpPr/>
-          <p:nvPr/>
-        </p:nvSpPr>
-        <p:spPr>
-          <a:xfrm>
-            <a:off x="9349511" y="2587752"/>
-            <a:ext cx="530352" cy="530352"/>
-          </a:xfrm>
-          <a:prstGeom prst="ellipse">
-            <a:avLst/>
-          </a:prstGeom>
-          <a:solidFill>
-            <a:srgbClr val="B0141C"/>
-          </a:solidFill>
-          <a:ln w="12700">
-            <a:solidFill>
-              <a:srgbClr val="B0141C"/>
-            </a:solidFill>
-            <a:prstDash val="solid"/>
-          </a:ln>
-        </p:spPr>
-      </p:sp>
-      <p:pic>
-        <p:nvPicPr>
-          <p:cNvPr id="54" name="Image 13" descr="preencoded.png"/>
-          <p:cNvPicPr>
-            <a:picLocks noChangeAspect="1"/>
-          </p:cNvPicPr>
-          <p:nvPr/>
-        </p:nvPicPr>
-        <p:blipFill>
-          <a:blip r:embed="rId8"/>
-          <a:stretch>
-            <a:fillRect/>
-          </a:stretch>
-        </p:blipFill>
-        <p:spPr>
-          <a:xfrm>
-            <a:off x="9487403" y="2725644"/>
-            <a:ext cx="254569" cy="254569"/>
-          </a:xfrm>
-          <a:prstGeom prst="rect">
-            <a:avLst/>
-          </a:prstGeom>
-        </p:spPr>
-      </p:pic>
-      <p:sp>
-        <p:nvSpPr>
-          <p:cNvPr id="55" name="Text 39"/>
-          <p:cNvSpPr txBox="1"/>
-          <p:nvPr/>
-        </p:nvSpPr>
-        <p:spPr>
-          <a:xfrm>
-            <a:off x="9989591" y="2587752"/>
-            <a:ext cx="1562024" cy="530352"/>
-          </a:xfrm>
-          <a:prstGeom prst="rect">
-            <a:avLst/>
-          </a:prstGeom>
-          <a:noFill/>
-          <a:ln/>
-        </p:spPr>
-        <p:txBody>
-          <a:bodyPr wrap="square" lIns="0" tIns="0" rIns="0" bIns="0" rtlCol="0" anchor="ctr"/>
-          <a:lstStyle/>
-          <a:p>
-            <a:pPr marL="0" indent="0">
-              <a:buNone/>
-            </a:pPr>
-            <a:r>
-              <a:rPr lang="en-US" sz="1000" b="1" kern="0" spc="100" dirty="0">
-                <a:solidFill>
-                  <a:srgbClr val="E3202A"/>
-                </a:solidFill>
-                <a:latin typeface="Calibri" pitchFamily="34" charset="0"/>
-                <a:ea typeface="Calibri" pitchFamily="34" charset="-122"/>
-                <a:cs typeface="Calibri" pitchFamily="34" charset="-120"/>
-              </a:rPr>
-              <a:t>PHASE 4  ·  WEEK 5+</a:t>
-            </a:r>
-            <a:endParaRPr lang="en-US" sz="1000" dirty="0"/>
-          </a:p>
-        </p:txBody>
-      </p:sp>
-      <p:sp>
-        <p:nvSpPr>
-          <p:cNvPr id="56" name="Text 40"/>
-          <p:cNvSpPr txBox="1"/>
-          <p:nvPr/>
-        </p:nvSpPr>
-        <p:spPr>
-          <a:xfrm>
-            <a:off x="9349511" y="3246120"/>
-            <a:ext cx="2110664" cy="329184"/>
-          </a:xfrm>
-          <a:prstGeom prst="rect">
-            <a:avLst/>
-          </a:prstGeom>
-          <a:noFill/>
-          <a:ln/>
-        </p:spPr>
-        <p:txBody>
-          <a:bodyPr wrap="square" lIns="0" tIns="0" rIns="0" bIns="0" rtlCol="0" anchor="t"/>
-          <a:lstStyle/>
-          <a:p>
-            <a:pPr marL="0" indent="0">
-              <a:buNone/>
-            </a:pPr>
-            <a:r>
-              <a:rPr lang="en-US" sz="1500" b="1" dirty="0">
-                <a:solidFill>
-                  <a:srgbClr val="151A21"/>
-                </a:solidFill>
-                <a:latin typeface="Arial" pitchFamily="34" charset="0"/>
-                <a:ea typeface="Arial" pitchFamily="34" charset="-122"/>
-                <a:cs typeface="Arial" pitchFamily="34" charset="-120"/>
-              </a:rPr>
-              <a:t>Operate &amp; Optimize</a:t>
-            </a:r>
-            <a:endParaRPr lang="en-US" sz="1500" dirty="0"/>
-          </a:p>
-        </p:txBody>
-      </p:sp>
-      <p:pic>
-        <p:nvPicPr>
-          <p:cNvPr id="57" name="Image 14" descr="preencoded.png"/>
-          <p:cNvPicPr>
-            <a:picLocks noChangeAspect="1"/>
-          </p:cNvPicPr>
-          <p:nvPr/>
-        </p:nvPicPr>
-        <p:blipFill>
-          <a:blip r:embed="rId5"/>
-          <a:stretch>
-            <a:fillRect/>
-          </a:stretch>
-        </p:blipFill>
-        <p:spPr>
-          <a:xfrm>
-            <a:off x="9349511" y="3749040"/>
-            <a:ext cx="164592" cy="164592"/>
-          </a:xfrm>
-          <a:prstGeom prst="rect">
-            <a:avLst/>
-          </a:prstGeom>
-        </p:spPr>
-      </p:pic>
-      <p:sp>
-        <p:nvSpPr>
-          <p:cNvPr id="58" name="Text 41"/>
-          <p:cNvSpPr txBox="1"/>
-          <p:nvPr/>
-        </p:nvSpPr>
-        <p:spPr>
-          <a:xfrm>
-            <a:off x="9623831" y="3703320"/>
-            <a:ext cx="1836344" cy="475488"/>
-          </a:xfrm>
-          <a:prstGeom prst="rect">
-            <a:avLst/>
-          </a:prstGeom>
-          <a:noFill/>
-          <a:ln/>
-        </p:spPr>
-        <p:txBody>
-          <a:bodyPr wrap="square" lIns="0" tIns="0" rIns="0" bIns="0" rtlCol="0" anchor="t"/>
-          <a:lstStyle/>
-          <a:p>
-            <a:pPr marL="0" indent="0">
-              <a:buNone/>
-            </a:pPr>
-            <a:r>
-              <a:rPr lang="en-US" sz="1150" dirty="0">
-                <a:solidFill>
-                  <a:srgbClr val="151A21"/>
-                </a:solidFill>
-                <a:latin typeface="Calibri" pitchFamily="34" charset="0"/>
-                <a:ea typeface="Calibri" pitchFamily="34" charset="-122"/>
-                <a:cs typeface="Calibri" pitchFamily="34" charset="-120"/>
-              </a:rPr>
-              <a:t>Policy tuning and alert review</a:t>
-            </a:r>
-            <a:endParaRPr lang="en-US" sz="1150" dirty="0"/>
-          </a:p>
-        </p:txBody>
-      </p:sp>
-      <p:pic>
-        <p:nvPicPr>
-          <p:cNvPr id="59" name="Image 15" descr="preencoded.png"/>
-          <p:cNvPicPr>
-            <a:picLocks noChangeAspect="1"/>
-          </p:cNvPicPr>
-          <p:nvPr/>
-        </p:nvPicPr>
-        <p:blipFill>
-          <a:blip r:embed="rId5"/>
-          <a:stretch>
-            <a:fillRect/>
-          </a:stretch>
-        </p:blipFill>
-        <p:spPr>
-          <a:xfrm>
-            <a:off x="9349511" y="4261104"/>
-            <a:ext cx="164592" cy="164592"/>
-          </a:xfrm>
-          <a:prstGeom prst="rect">
-            <a:avLst/>
-          </a:prstGeom>
-        </p:spPr>
-      </p:pic>
-      <p:sp>
-        <p:nvSpPr>
-          <p:cNvPr id="60" name="Text 42"/>
-          <p:cNvSpPr txBox="1"/>
-          <p:nvPr/>
-        </p:nvSpPr>
-        <p:spPr>
-          <a:xfrm>
-            <a:off x="9623831" y="4215384"/>
-            <a:ext cx="1836344" cy="475488"/>
-          </a:xfrm>
-          <a:prstGeom prst="rect">
-            <a:avLst/>
-          </a:prstGeom>
-          <a:noFill/>
-          <a:ln/>
-        </p:spPr>
-        <p:txBody>
-          <a:bodyPr wrap="square" lIns="0" tIns="0" rIns="0" bIns="0" rtlCol="0" anchor="t"/>
-          <a:lstStyle/>
-          <a:p>
-            <a:pPr marL="0" indent="0">
-              <a:buNone/>
-            </a:pPr>
-            <a:r>
-              <a:rPr lang="en-US" sz="1150" dirty="0">
-                <a:solidFill>
-                  <a:srgbClr val="151A21"/>
-                </a:solidFill>
-                <a:latin typeface="Calibri" pitchFamily="34" charset="0"/>
-                <a:ea typeface="Calibri" pitchFamily="34" charset="-122"/>
-                <a:cs typeface="Calibri" pitchFamily="34" charset="-120"/>
-              </a:rPr>
-              <a:t>Handover to 24/7 support</a:t>
-            </a:r>
-            <a:endParaRPr lang="en-US" sz="1150" dirty="0"/>
-          </a:p>
-        </p:txBody>
-      </p:sp>
-      <p:pic>
-        <p:nvPicPr>
-          <p:cNvPr id="61" name="Image 16" descr="preencoded.png"/>
-          <p:cNvPicPr>
-            <a:picLocks noChangeAspect="1"/>
-          </p:cNvPicPr>
-          <p:nvPr/>
-        </p:nvPicPr>
-        <p:blipFill>
-          <a:blip r:embed="rId5"/>
-          <a:stretch>
-            <a:fillRect/>
-          </a:stretch>
-        </p:blipFill>
-        <p:spPr>
-          <a:xfrm>
-            <a:off x="9349511" y="4773168"/>
-            <a:ext cx="164592" cy="164592"/>
-          </a:xfrm>
-          <a:prstGeom prst="rect">
-            <a:avLst/>
-          </a:prstGeom>
-        </p:spPr>
-      </p:pic>
-      <p:sp>
-        <p:nvSpPr>
-          <p:cNvPr id="62" name="Text 43"/>
-          <p:cNvSpPr txBox="1"/>
-          <p:nvPr/>
-        </p:nvSpPr>
-        <p:spPr>
-          <a:xfrm>
-            <a:off x="9623831" y="4727448"/>
-            <a:ext cx="1836344" cy="475488"/>
-          </a:xfrm>
-          <a:prstGeom prst="rect">
-            <a:avLst/>
-          </a:prstGeom>
-          <a:noFill/>
-          <a:ln/>
-        </p:spPr>
-        <p:txBody>
-          <a:bodyPr wrap="square" lIns="0" tIns="0" rIns="0" bIns="0" rtlCol="0" anchor="t"/>
-          <a:lstStyle/>
-          <a:p>
-            <a:pPr marL="0" indent="0">
-              <a:buNone/>
-            </a:pPr>
-            <a:r>
-              <a:rPr lang="en-US" sz="1150" dirty="0">
-                <a:solidFill>
-                  <a:srgbClr val="151A21"/>
-                </a:solidFill>
-                <a:latin typeface="Calibri" pitchFamily="34" charset="0"/>
-                <a:ea typeface="Calibri" pitchFamily="34" charset="-122"/>
-                <a:cs typeface="Calibri" pitchFamily="34" charset="-120"/>
-              </a:rPr>
-              <a:t>Monthly security reports to management</a:t>
-            </a:r>
-            <a:endParaRPr lang="en-US" sz="1150" dirty="0"/>
-          </a:p>
-        </p:txBody>
-      </p:sp>
-      <p:sp>
-        <p:nvSpPr>
-          <p:cNvPr id="63" name="Shape 44"/>
-          <p:cNvSpPr/>
-          <p:nvPr/>
-        </p:nvSpPr>
-        <p:spPr>
-          <a:xfrm>
-            <a:off x="548640" y="5504688"/>
-            <a:ext cx="3515258" cy="502920"/>
-          </a:xfrm>
-          <a:prstGeom prst="roundRect">
-            <a:avLst>
-              <a:gd name="adj" fmla="val 50000"/>
-            </a:avLst>
-          </a:prstGeom>
-          <a:solidFill>
-            <a:srgbClr val="FFFFFF"/>
-          </a:solidFill>
-          <a:ln w="9525">
-            <a:solidFill>
-              <a:srgbClr val="DCE1E7"/>
-            </a:solidFill>
-            <a:prstDash val="solid"/>
-          </a:ln>
-        </p:spPr>
-      </p:sp>
-      <p:pic>
-        <p:nvPicPr>
-          <p:cNvPr id="64" name="Image 17" descr="preencoded.png"/>
-          <p:cNvPicPr>
-            <a:picLocks noChangeAspect="1"/>
-          </p:cNvPicPr>
-          <p:nvPr/>
-        </p:nvPicPr>
-        <p:blipFill>
-          <a:blip r:embed="rId9"/>
-          <a:stretch>
-            <a:fillRect/>
-          </a:stretch>
-        </p:blipFill>
-        <p:spPr>
-          <a:xfrm>
-            <a:off x="777240" y="5641848"/>
-            <a:ext cx="228600" cy="228600"/>
-          </a:xfrm>
-          <a:prstGeom prst="rect">
-            <a:avLst/>
-          </a:prstGeom>
-        </p:spPr>
-      </p:pic>
-      <p:sp>
-        <p:nvSpPr>
-          <p:cNvPr id="65" name="Text 45"/>
-          <p:cNvSpPr txBox="1"/>
-          <p:nvPr/>
-        </p:nvSpPr>
-        <p:spPr>
-          <a:xfrm>
-            <a:off x="1143000" y="5504688"/>
-            <a:ext cx="2783738" cy="502920"/>
-          </a:xfrm>
-          <a:prstGeom prst="rect">
-            <a:avLst/>
-          </a:prstGeom>
-          <a:noFill/>
-          <a:ln/>
-        </p:spPr>
-        <p:txBody>
-          <a:bodyPr wrap="square" lIns="0" tIns="0" rIns="0" bIns="0" rtlCol="0" anchor="ctr"/>
-          <a:lstStyle/>
-          <a:p>
-            <a:pPr marL="0" indent="0">
-              <a:buNone/>
-            </a:pPr>
-            <a:r>
-              <a:rPr lang="en-US" sz="1150" b="1" dirty="0">
-                <a:solidFill>
-                  <a:srgbClr val="151A21"/>
-                </a:solidFill>
-                <a:latin typeface="Calibri" pitchFamily="34" charset="0"/>
-                <a:ea typeface="Calibri" pitchFamily="34" charset="-122"/>
-                <a:cs typeface="Calibri" pitchFamily="34" charset="-120"/>
-              </a:rPr>
-              <a:t>No on-site server required</a:t>
-            </a:r>
-            <a:endParaRPr lang="en-US" sz="1150" dirty="0"/>
-          </a:p>
-        </p:txBody>
-      </p:sp>
-      <p:sp>
-        <p:nvSpPr>
-          <p:cNvPr id="66" name="Shape 46"/>
-          <p:cNvSpPr/>
-          <p:nvPr/>
-        </p:nvSpPr>
-        <p:spPr>
-          <a:xfrm>
-            <a:off x="4338218" y="5504688"/>
-            <a:ext cx="3515258" cy="502920"/>
-          </a:xfrm>
-          <a:prstGeom prst="roundRect">
-            <a:avLst>
-              <a:gd name="adj" fmla="val 50000"/>
-            </a:avLst>
-          </a:prstGeom>
-          <a:solidFill>
-            <a:srgbClr val="FFFFFF"/>
-          </a:solidFill>
-          <a:ln w="9525">
-            <a:solidFill>
-              <a:srgbClr val="DCE1E7"/>
-            </a:solidFill>
-            <a:prstDash val="solid"/>
-          </a:ln>
-        </p:spPr>
-      </p:sp>
-      <p:pic>
-        <p:nvPicPr>
-          <p:cNvPr id="67" name="Image 18" descr="preencoded.png"/>
-          <p:cNvPicPr>
-            <a:picLocks noChangeAspect="1"/>
-          </p:cNvPicPr>
-          <p:nvPr/>
-        </p:nvPicPr>
-        <p:blipFill>
-          <a:blip r:embed="rId10"/>
-          <a:stretch>
-            <a:fillRect/>
-          </a:stretch>
-        </p:blipFill>
-        <p:spPr>
-          <a:xfrm>
-            <a:off x="4566818" y="5641848"/>
-            <a:ext cx="228600" cy="228600"/>
-          </a:xfrm>
-          <a:prstGeom prst="rect">
-            <a:avLst/>
-          </a:prstGeom>
-        </p:spPr>
-      </p:pic>
-      <p:sp>
-        <p:nvSpPr>
-          <p:cNvPr id="68" name="Text 47"/>
-          <p:cNvSpPr txBox="1"/>
-          <p:nvPr/>
-        </p:nvSpPr>
-        <p:spPr>
-          <a:xfrm>
-            <a:off x="4932578" y="5504688"/>
-            <a:ext cx="2783738" cy="502920"/>
-          </a:xfrm>
-          <a:prstGeom prst="rect">
-            <a:avLst/>
-          </a:prstGeom>
-          <a:noFill/>
-          <a:ln/>
-        </p:spPr>
-        <p:txBody>
-          <a:bodyPr wrap="square" lIns="0" tIns="0" rIns="0" bIns="0" rtlCol="0" anchor="ctr"/>
-          <a:lstStyle/>
-          <a:p>
-            <a:pPr marL="0" indent="0">
-              <a:buNone/>
-            </a:pPr>
-            <a:r>
-              <a:rPr lang="en-US" sz="1150" b="1" dirty="0">
-                <a:solidFill>
-                  <a:srgbClr val="151A21"/>
-                </a:solidFill>
-                <a:latin typeface="Calibri" pitchFamily="34" charset="0"/>
-                <a:ea typeface="Calibri" pitchFamily="34" charset="-122"/>
-                <a:cs typeface="Calibri" pitchFamily="34" charset="-120"/>
-              </a:rPr>
-              <a:t>Remote deployment — minimal on-site work</a:t>
-            </a:r>
-            <a:endParaRPr lang="en-US" sz="1150" dirty="0"/>
-          </a:p>
-        </p:txBody>
-      </p:sp>
-      <p:sp>
-        <p:nvSpPr>
-          <p:cNvPr id="69" name="Shape 48"/>
-          <p:cNvSpPr/>
-          <p:nvPr/>
-        </p:nvSpPr>
-        <p:spPr>
-          <a:xfrm>
-            <a:off x="8127797" y="5504688"/>
-            <a:ext cx="3515258" cy="502920"/>
-          </a:xfrm>
-          <a:prstGeom prst="roundRect">
-            <a:avLst>
-              <a:gd name="adj" fmla="val 50000"/>
-            </a:avLst>
-          </a:prstGeom>
-          <a:solidFill>
-            <a:srgbClr val="FFFFFF"/>
-          </a:solidFill>
-          <a:ln w="9525">
-            <a:solidFill>
-              <a:srgbClr val="DCE1E7"/>
-            </a:solidFill>
-            <a:prstDash val="solid"/>
-          </a:ln>
-        </p:spPr>
-      </p:sp>
-      <p:pic>
-        <p:nvPicPr>
-          <p:cNvPr id="70" name="Image 19" descr="preencoded.png"/>
-          <p:cNvPicPr>
-            <a:picLocks noChangeAspect="1"/>
-          </p:cNvPicPr>
-          <p:nvPr/>
-        </p:nvPicPr>
-        <p:blipFill>
-          <a:blip r:embed="rId11"/>
-          <a:stretch>
-            <a:fillRect/>
-          </a:stretch>
-        </p:blipFill>
-        <p:spPr>
-          <a:xfrm>
-            <a:off x="8356397" y="5641848"/>
-            <a:ext cx="228600" cy="228600"/>
-          </a:xfrm>
-          <a:prstGeom prst="rect">
-            <a:avLst/>
-          </a:prstGeom>
-        </p:spPr>
-      </p:pic>
-      <p:sp>
-        <p:nvSpPr>
-          <p:cNvPr id="71" name="Text 49"/>
-          <p:cNvSpPr txBox="1"/>
-          <p:nvPr/>
-        </p:nvSpPr>
-        <p:spPr>
-          <a:xfrm>
-            <a:off x="8722157" y="5504688"/>
-            <a:ext cx="2783738" cy="502920"/>
-          </a:xfrm>
-          <a:prstGeom prst="rect">
-            <a:avLst/>
-          </a:prstGeom>
-          <a:noFill/>
-          <a:ln/>
-        </p:spPr>
-        <p:txBody>
-          <a:bodyPr wrap="square" lIns="0" tIns="0" rIns="0" bIns="0" rtlCol="0" anchor="ctr"/>
-          <a:lstStyle/>
-          <a:p>
-            <a:pPr marL="0" indent="0">
-              <a:buNone/>
-            </a:pPr>
-            <a:r>
-              <a:rPr lang="en-US" sz="1150" b="1" dirty="0">
-                <a:solidFill>
-                  <a:srgbClr val="151A21"/>
-                </a:solidFill>
-                <a:latin typeface="Calibri" pitchFamily="34" charset="0"/>
-                <a:ea typeface="Calibri" pitchFamily="34" charset="-122"/>
-                <a:cs typeface="Calibri" pitchFamily="34" charset="-120"/>
-              </a:rPr>
-              <a:t>Final timeline confirmed after Phase 1</a:t>
-            </a:r>
-            <a:endParaRPr lang="en-US" sz="1150" dirty="0"/>
-          </a:p>
-        </p:txBody>
-      </p:sp>
-      <p:sp>
-        <p:nvSpPr>
-          <p:cNvPr id="72" name="Text 50"/>
-          <p:cNvSpPr txBox="1"/>
-          <p:nvPr/>
-        </p:nvSpPr>
-        <p:spPr>
-          <a:xfrm>
-            <a:off x="548640" y="6446520"/>
-            <a:ext cx="7315200" cy="219456"/>
-          </a:xfrm>
-          <a:prstGeom prst="rect">
-            <a:avLst/>
-          </a:prstGeom>
-          <a:noFill/>
-          <a:ln/>
-        </p:spPr>
-        <p:txBody>
-          <a:bodyPr wrap="square" lIns="0" tIns="0" rIns="0" bIns="0" rtlCol="0" anchor="ctr"/>
-          <a:lstStyle/>
-          <a:p>
-            <a:pPr marL="0" indent="0">
-              <a:buNone/>
-            </a:pPr>
-            <a:r>
-              <a:rPr lang="en-US" sz="900" dirty="0">
-                <a:solidFill>
-                  <a:srgbClr val="5E6978"/>
-                </a:solidFill>
-                <a:latin typeface="Calibri" pitchFamily="34" charset="0"/>
-                <a:ea typeface="Calibri" pitchFamily="34" charset="-122"/>
-                <a:cs typeface="Calibri" pitchFamily="34" charset="-120"/>
-              </a:rPr>
-              <a:t>16   |   Nessus vs. CrowdStrike Falcon Platform  ·  Proposal for The Westin Resort Guam</a:t>
-            </a:r>
-            <a:endParaRPr lang="en-US" sz="900" dirty="0"/>
-          </a:p>
-        </p:txBody>
-      </p:sp>
-      <p:pic>
-        <p:nvPicPr>
-          <p:cNvPr id="73" name="Image 20" descr="/private/tmp/claude-501/-Users-jihanvin-Desktop-NIVNAH-AI/16a96446-d9b3-40e2-af9e-a3011ae3db84/scratchpad/assets/secukorea_dark.png"/>
-          <p:cNvPicPr>
-            <a:picLocks noChangeAspect="1"/>
-          </p:cNvPicPr>
-          <p:nvPr/>
-        </p:nvPicPr>
-        <p:blipFill>
-          <a:blip r:embed="rId12"/>
-          <a:stretch>
-            <a:fillRect/>
-          </a:stretch>
-        </p:blipFill>
-        <p:spPr>
-          <a:xfrm>
-            <a:off x="10661904" y="6400800"/>
-            <a:ext cx="978408" cy="233172"/>
-          </a:xfrm>
-          <a:prstGeom prst="rect">
-            <a:avLst/>
-          </a:prstGeom>
-        </p:spPr>
-      </p:pic>
-    </p:spTree>
-  </p:cSld>
-  <p:clrMapOvr>
-    <a:masterClrMapping/>
-  </p:clrMapOvr>
-</p:sld>
-</file>
-
 <file path=ppt/slides/slide18.xml><?xml version="1.0" encoding="utf-8"?>
 <p:sld xmlns:a="http://schemas.openxmlformats.org/drawingml/2006/main" xmlns:r="http://schemas.openxmlformats.org/officeDocument/2006/relationships" xmlns:p="http://schemas.openxmlformats.org/presentationml/2006/main">
   <p:cSld name="Slide 3">
@@ -15810,7 +12892,7 @@
                 <a:ea typeface="Arial" pitchFamily="34" charset="-122"/>
                 <a:cs typeface="Arial" pitchFamily="34" charset="-120"/>
               </a:rPr>
-              <a:t>15   TECHNICAL SUPPORT</a:t>
+              <a:t>14   TECHNICAL SUPPORT</a:t>
             </a:r>
             <a:endParaRPr lang="en-US" sz="1100" dirty="0"/>
           </a:p>
@@ -16695,7 +13777,7 @@
                 <a:ea typeface="Calibri" pitchFamily="34" charset="-122"/>
                 <a:cs typeface="Calibri" pitchFamily="34" charset="-120"/>
               </a:rPr>
-              <a:t>17   |   Nessus vs. CrowdStrike Falcon Platform  ·  Proposal for The Westin Resort Guam</a:t>
+              <a:t>16   |   Nessus vs. CrowdStrike Falcon Platform  ·  Proposal for The Westin Resort Guam</a:t>
             </a:r>
             <a:endParaRPr lang="en-US" sz="900" dirty="0"/>
           </a:p>
@@ -16821,7 +13903,7 @@
                 <a:ea typeface="Arial" pitchFamily="34" charset="-122"/>
                 <a:cs typeface="Arial" pitchFamily="34" charset="-120"/>
               </a:rPr>
-              <a:t>16   EXPECTED BENEFITS</a:t>
+              <a:t>15   EXPECTED BENEFITS</a:t>
             </a:r>
             <a:endParaRPr lang="en-US" sz="1100" dirty="0"/>
           </a:p>
@@ -18361,7 +15443,7 @@
                 <a:ea typeface="Calibri" pitchFamily="34" charset="-122"/>
                 <a:cs typeface="Calibri" pitchFamily="34" charset="-120"/>
               </a:rPr>
-              <a:t>18   |   Nessus vs. CrowdStrike Falcon Platform  ·  Proposal for The Westin Resort Guam</a:t>
+              <a:t>17   |   Nessus vs. CrowdStrike Falcon Platform  ·  Proposal for The Westin Resort Guam</a:t>
             </a:r>
             <a:endParaRPr lang="en-US" sz="900" dirty="0"/>
           </a:p>
@@ -19577,1094 +16659,6 @@
         </p:nvPicPr>
         <p:blipFill>
           <a:blip r:embed="rId7"/>
-          <a:stretch>
-            <a:fillRect/>
-          </a:stretch>
-        </p:blipFill>
-        <p:spPr>
-          <a:xfrm>
-            <a:off x="10661904" y="6400800"/>
-            <a:ext cx="978408" cy="233172"/>
-          </a:xfrm>
-          <a:prstGeom prst="rect">
-            <a:avLst/>
-          </a:prstGeom>
-        </p:spPr>
-      </p:pic>
-    </p:spTree>
-  </p:cSld>
-  <p:clrMapOvr>
-    <a:masterClrMapping/>
-  </p:clrMapOvr>
-</p:sld>
-</file>
-
-<file path=ppt/slides/slide20.xml><?xml version="1.0" encoding="utf-8"?>
-<p:sld xmlns:a="http://schemas.openxmlformats.org/drawingml/2006/main" xmlns:r="http://schemas.openxmlformats.org/officeDocument/2006/relationships" xmlns:p="http://schemas.openxmlformats.org/presentationml/2006/main">
-  <p:cSld name="Slide 19">
-    <p:bg>
-      <p:bgPr>
-        <a:solidFill>
-          <a:srgbClr val="FFFFFF"/>
-        </a:solidFill>
-        <a:effectLst/>
-      </p:bgPr>
-    </p:bg>
-    <p:spTree>
-      <p:nvGrpSpPr>
-        <p:cNvPr id="1" name=""/>
-        <p:cNvGrpSpPr/>
-        <p:nvPr/>
-      </p:nvGrpSpPr>
-      <p:grpSpPr>
-        <a:xfrm>
-          <a:off x="0" y="0"/>
-          <a:ext cx="0" cy="0"/>
-          <a:chOff x="0" y="0"/>
-          <a:chExt cx="0" cy="0"/>
-        </a:xfrm>
-      </p:grpSpPr>
-      <p:sp>
-        <p:nvSpPr>
-          <p:cNvPr id="2" name="Text 0"/>
-          <p:cNvSpPr txBox="1"/>
-          <p:nvPr/>
-        </p:nvSpPr>
-        <p:spPr>
-          <a:xfrm>
-            <a:off x="548640" y="384048"/>
-            <a:ext cx="8229600" cy="256032"/>
-          </a:xfrm>
-          <a:prstGeom prst="rect">
-            <a:avLst/>
-          </a:prstGeom>
-          <a:noFill/>
-          <a:ln/>
-        </p:spPr>
-        <p:txBody>
-          <a:bodyPr wrap="square" lIns="0" tIns="0" rIns="0" bIns="0" rtlCol="0" anchor="t"/>
-          <a:lstStyle/>
-          <a:p>
-            <a:pPr marL="0" indent="0">
-              <a:buNone/>
-            </a:pPr>
-            <a:r>
-              <a:rPr lang="en-US" sz="1100" b="1" kern="0" spc="200" dirty="0">
-                <a:solidFill>
-                  <a:srgbClr val="E3202A"/>
-                </a:solidFill>
-                <a:latin typeface="Arial" pitchFamily="34" charset="0"/>
-                <a:ea typeface="Arial" pitchFamily="34" charset="-122"/>
-                <a:cs typeface="Arial" pitchFamily="34" charset="-120"/>
-              </a:rPr>
-              <a:t>17   NEXT STEPS</a:t>
-            </a:r>
-            <a:endParaRPr lang="en-US" sz="1100" dirty="0"/>
-          </a:p>
-        </p:txBody>
-      </p:sp>
-      <p:sp>
-        <p:nvSpPr>
-          <p:cNvPr id="3" name="Text 1"/>
-          <p:cNvSpPr txBox="1"/>
-          <p:nvPr/>
-        </p:nvSpPr>
-        <p:spPr>
-          <a:xfrm>
-            <a:off x="548640" y="658368"/>
-            <a:ext cx="9692640" cy="658368"/>
-          </a:xfrm>
-          <a:prstGeom prst="rect">
-            <a:avLst/>
-          </a:prstGeom>
-          <a:noFill/>
-          <a:ln/>
-        </p:spPr>
-        <p:txBody>
-          <a:bodyPr wrap="square" lIns="0" tIns="0" rIns="0" bIns="0" rtlCol="0" anchor="ctr"/>
-          <a:lstStyle/>
-          <a:p>
-            <a:pPr marL="0" indent="0">
-              <a:buNone/>
-            </a:pPr>
-            <a:r>
-              <a:rPr lang="en-US" sz="2800" b="1" dirty="0">
-                <a:solidFill>
-                  <a:srgbClr val="151A21"/>
-                </a:solidFill>
-                <a:latin typeface="Arial" pitchFamily="34" charset="0"/>
-                <a:ea typeface="Arial" pitchFamily="34" charset="-122"/>
-                <a:cs typeface="Arial" pitchFamily="34" charset="-120"/>
-              </a:rPr>
-              <a:t>Proposed Next Steps</a:t>
-            </a:r>
-            <a:endParaRPr lang="en-US" sz="2800" dirty="0"/>
-          </a:p>
-        </p:txBody>
-      </p:sp>
-      <p:pic>
-        <p:nvPicPr>
-          <p:cNvPr id="4" name="Image 0" descr="/private/tmp/claude-501/-Users-jihanvin-Desktop-NIVNAH-AI/16a96446-d9b3-40e2-af9e-a3011ae3db84/scratchpad/assets/westin_grey.png"/>
-          <p:cNvPicPr>
-            <a:picLocks noChangeAspect="1"/>
-          </p:cNvPicPr>
-          <p:nvPr/>
-        </p:nvPicPr>
-        <p:blipFill>
-          <a:blip r:embed="rId3"/>
-          <a:stretch>
-            <a:fillRect/>
-          </a:stretch>
-        </p:blipFill>
-        <p:spPr>
-          <a:xfrm>
-            <a:off x="10634472" y="402336"/>
-            <a:ext cx="1005840" cy="301752"/>
-          </a:xfrm>
-          <a:prstGeom prst="rect">
-            <a:avLst/>
-          </a:prstGeom>
-        </p:spPr>
-      </p:pic>
-      <p:sp>
-        <p:nvSpPr>
-          <p:cNvPr id="5" name="Text 2"/>
-          <p:cNvSpPr txBox="1"/>
-          <p:nvPr/>
-        </p:nvSpPr>
-        <p:spPr>
-          <a:xfrm>
-            <a:off x="548640" y="1691640"/>
-            <a:ext cx="1097280" cy="731520"/>
-          </a:xfrm>
-          <a:prstGeom prst="rect">
-            <a:avLst/>
-          </a:prstGeom>
-          <a:noFill/>
-          <a:ln/>
-        </p:spPr>
-        <p:txBody>
-          <a:bodyPr wrap="square" lIns="0" tIns="0" rIns="0" bIns="0" rtlCol="0" anchor="ctr"/>
-          <a:lstStyle/>
-          <a:p>
-            <a:pPr marL="0" indent="0">
-              <a:buNone/>
-            </a:pPr>
-            <a:r>
-              <a:rPr lang="en-US" sz="4400" b="1" dirty="0">
-                <a:solidFill>
-                  <a:srgbClr val="E3202A"/>
-                </a:solidFill>
-                <a:latin typeface="Arial" pitchFamily="34" charset="0"/>
-                <a:ea typeface="Arial" pitchFamily="34" charset="-122"/>
-                <a:cs typeface="Arial" pitchFamily="34" charset="-120"/>
-              </a:rPr>
-              <a:t>01</a:t>
-            </a:r>
-            <a:endParaRPr lang="en-US" sz="4400" dirty="0"/>
-          </a:p>
-        </p:txBody>
-      </p:sp>
-      <p:sp>
-        <p:nvSpPr>
-          <p:cNvPr id="6" name="Shape 3"/>
-          <p:cNvSpPr/>
-          <p:nvPr/>
-        </p:nvSpPr>
-        <p:spPr>
-          <a:xfrm>
-            <a:off x="2549576" y="1801368"/>
-            <a:ext cx="512064" cy="512064"/>
-          </a:xfrm>
-          <a:prstGeom prst="roundRect">
-            <a:avLst>
-              <a:gd name="adj" fmla="val 17857"/>
-            </a:avLst>
-          </a:prstGeom>
-          <a:solidFill>
-            <a:srgbClr val="E3202A"/>
-          </a:solidFill>
-          <a:ln w="12700">
-            <a:solidFill>
-              <a:srgbClr val="E3202A"/>
-            </a:solidFill>
-            <a:prstDash val="solid"/>
-          </a:ln>
-        </p:spPr>
-      </p:sp>
-      <p:pic>
-        <p:nvPicPr>
-          <p:cNvPr id="7" name="Image 1" descr="preencoded.png"/>
-          <p:cNvPicPr>
-            <a:picLocks noChangeAspect="1"/>
-          </p:cNvPicPr>
-          <p:nvPr/>
-        </p:nvPicPr>
-        <p:blipFill>
-          <a:blip r:embed="rId4"/>
-          <a:stretch>
-            <a:fillRect/>
-          </a:stretch>
-        </p:blipFill>
-        <p:spPr>
-          <a:xfrm>
-            <a:off x="2662230" y="1914022"/>
-            <a:ext cx="286756" cy="286756"/>
-          </a:xfrm>
-          <a:prstGeom prst="rect">
-            <a:avLst/>
-          </a:prstGeom>
-        </p:spPr>
-      </p:pic>
-      <p:sp>
-        <p:nvSpPr>
-          <p:cNvPr id="8" name="Shape 4"/>
-          <p:cNvSpPr/>
-          <p:nvPr/>
-        </p:nvSpPr>
-        <p:spPr>
-          <a:xfrm>
-            <a:off x="548640" y="2587752"/>
-            <a:ext cx="2567864" cy="0"/>
-          </a:xfrm>
-          <a:prstGeom prst="line">
-            <a:avLst/>
-          </a:prstGeom>
-          <a:noFill/>
-          <a:ln w="25400">
-            <a:solidFill>
-              <a:srgbClr val="E3202A"/>
-            </a:solidFill>
-            <a:prstDash val="solid"/>
-          </a:ln>
-        </p:spPr>
-      </p:sp>
-      <p:sp>
-        <p:nvSpPr>
-          <p:cNvPr id="9" name="Text 5"/>
-          <p:cNvSpPr txBox="1"/>
-          <p:nvPr/>
-        </p:nvSpPr>
-        <p:spPr>
-          <a:xfrm>
-            <a:off x="548640" y="2743200"/>
-            <a:ext cx="2567864" cy="329184"/>
-          </a:xfrm>
-          <a:prstGeom prst="rect">
-            <a:avLst/>
-          </a:prstGeom>
-          <a:noFill/>
-          <a:ln/>
-        </p:spPr>
-        <p:txBody>
-          <a:bodyPr wrap="square" lIns="0" tIns="0" rIns="0" bIns="0" rtlCol="0" anchor="t"/>
-          <a:lstStyle/>
-          <a:p>
-            <a:pPr marL="0" indent="0">
-              <a:buNone/>
-            </a:pPr>
-            <a:r>
-              <a:rPr lang="en-US" sz="1500" b="1" dirty="0">
-                <a:solidFill>
-                  <a:srgbClr val="151A21"/>
-                </a:solidFill>
-                <a:latin typeface="Arial" pitchFamily="34" charset="0"/>
-                <a:ea typeface="Arial" pitchFamily="34" charset="-122"/>
-                <a:cs typeface="Arial" pitchFamily="34" charset="-120"/>
-              </a:rPr>
-              <a:t>Scoping workshop</a:t>
-            </a:r>
-            <a:endParaRPr lang="en-US" sz="1500" dirty="0"/>
-          </a:p>
-        </p:txBody>
-      </p:sp>
-      <p:sp>
-        <p:nvSpPr>
-          <p:cNvPr id="10" name="Text 6"/>
-          <p:cNvSpPr txBox="1"/>
-          <p:nvPr/>
-        </p:nvSpPr>
-        <p:spPr>
-          <a:xfrm>
-            <a:off x="548640" y="3108960"/>
-            <a:ext cx="2567864" cy="914400"/>
-          </a:xfrm>
-          <a:prstGeom prst="rect">
-            <a:avLst/>
-          </a:prstGeom>
-          <a:noFill/>
-          <a:ln/>
-        </p:spPr>
-        <p:txBody>
-          <a:bodyPr wrap="square" lIns="0" tIns="0" rIns="0" bIns="0" rtlCol="0" anchor="t"/>
-          <a:lstStyle/>
-          <a:p>
-            <a:pPr marL="0" indent="0">
-              <a:buNone/>
-            </a:pPr>
-            <a:r>
-              <a:rPr lang="en-US" sz="1200" dirty="0">
-                <a:solidFill>
-                  <a:srgbClr val="5E6978"/>
-                </a:solidFill>
-                <a:latin typeface="Calibri" pitchFamily="34" charset="0"/>
-                <a:ea typeface="Calibri" pitchFamily="34" charset="-122"/>
-                <a:cs typeface="Calibri" pitchFamily="34" charset="-120"/>
-              </a:rPr>
-              <a:t>Confirm endpoint count, operating systems and critical systems in a short remote session.</a:t>
-            </a:r>
-            <a:endParaRPr lang="en-US" sz="1200" dirty="0"/>
-          </a:p>
-        </p:txBody>
-      </p:sp>
-      <p:sp>
-        <p:nvSpPr>
-          <p:cNvPr id="11" name="Text 7"/>
-          <p:cNvSpPr txBox="1"/>
-          <p:nvPr/>
-        </p:nvSpPr>
-        <p:spPr>
-          <a:xfrm>
-            <a:off x="3390824" y="1691640"/>
-            <a:ext cx="1097280" cy="731520"/>
-          </a:xfrm>
-          <a:prstGeom prst="rect">
-            <a:avLst/>
-          </a:prstGeom>
-          <a:noFill/>
-          <a:ln/>
-        </p:spPr>
-        <p:txBody>
-          <a:bodyPr wrap="square" lIns="0" tIns="0" rIns="0" bIns="0" rtlCol="0" anchor="ctr"/>
-          <a:lstStyle/>
-          <a:p>
-            <a:pPr marL="0" indent="0">
-              <a:buNone/>
-            </a:pPr>
-            <a:r>
-              <a:rPr lang="en-US" sz="4400" b="1" dirty="0">
-                <a:solidFill>
-                  <a:srgbClr val="D5DAE1"/>
-                </a:solidFill>
-                <a:latin typeface="Arial" pitchFamily="34" charset="0"/>
-                <a:ea typeface="Arial" pitchFamily="34" charset="-122"/>
-                <a:cs typeface="Arial" pitchFamily="34" charset="-120"/>
-              </a:rPr>
-              <a:t>02</a:t>
-            </a:r>
-            <a:endParaRPr lang="en-US" sz="4400" dirty="0"/>
-          </a:p>
-        </p:txBody>
-      </p:sp>
-      <p:sp>
-        <p:nvSpPr>
-          <p:cNvPr id="12" name="Shape 8"/>
-          <p:cNvSpPr/>
-          <p:nvPr/>
-        </p:nvSpPr>
-        <p:spPr>
-          <a:xfrm>
-            <a:off x="5391760" y="1801368"/>
-            <a:ext cx="512064" cy="512064"/>
-          </a:xfrm>
-          <a:prstGeom prst="roundRect">
-            <a:avLst>
-              <a:gd name="adj" fmla="val 17857"/>
-            </a:avLst>
-          </a:prstGeom>
-          <a:solidFill>
-            <a:srgbClr val="EAEEF3"/>
-          </a:solidFill>
-          <a:ln w="12700">
-            <a:solidFill>
-              <a:srgbClr val="EAEEF3"/>
-            </a:solidFill>
-            <a:prstDash val="solid"/>
-          </a:ln>
-        </p:spPr>
-      </p:sp>
-      <p:pic>
-        <p:nvPicPr>
-          <p:cNvPr id="13" name="Image 2" descr="preencoded.png"/>
-          <p:cNvPicPr>
-            <a:picLocks noChangeAspect="1"/>
-          </p:cNvPicPr>
-          <p:nvPr/>
-        </p:nvPicPr>
-        <p:blipFill>
-          <a:blip r:embed="rId5"/>
-          <a:stretch>
-            <a:fillRect/>
-          </a:stretch>
-        </p:blipFill>
-        <p:spPr>
-          <a:xfrm>
-            <a:off x="5504414" y="1914022"/>
-            <a:ext cx="286756" cy="286756"/>
-          </a:xfrm>
-          <a:prstGeom prst="rect">
-            <a:avLst/>
-          </a:prstGeom>
-        </p:spPr>
-      </p:pic>
-      <p:sp>
-        <p:nvSpPr>
-          <p:cNvPr id="14" name="Shape 9"/>
-          <p:cNvSpPr/>
-          <p:nvPr/>
-        </p:nvSpPr>
-        <p:spPr>
-          <a:xfrm>
-            <a:off x="3390824" y="2587752"/>
-            <a:ext cx="2567864" cy="0"/>
-          </a:xfrm>
-          <a:prstGeom prst="line">
-            <a:avLst/>
-          </a:prstGeom>
-          <a:noFill/>
-          <a:ln w="25400">
-            <a:solidFill>
-              <a:srgbClr val="DCE1E7"/>
-            </a:solidFill>
-            <a:prstDash val="solid"/>
-          </a:ln>
-        </p:spPr>
-      </p:sp>
-      <p:sp>
-        <p:nvSpPr>
-          <p:cNvPr id="15" name="Text 10"/>
-          <p:cNvSpPr txBox="1"/>
-          <p:nvPr/>
-        </p:nvSpPr>
-        <p:spPr>
-          <a:xfrm>
-            <a:off x="3390824" y="2743200"/>
-            <a:ext cx="2567864" cy="329184"/>
-          </a:xfrm>
-          <a:prstGeom prst="rect">
-            <a:avLst/>
-          </a:prstGeom>
-          <a:noFill/>
-          <a:ln/>
-        </p:spPr>
-        <p:txBody>
-          <a:bodyPr wrap="square" lIns="0" tIns="0" rIns="0" bIns="0" rtlCol="0" anchor="t"/>
-          <a:lstStyle/>
-          <a:p>
-            <a:pPr marL="0" indent="0">
-              <a:buNone/>
-            </a:pPr>
-            <a:r>
-              <a:rPr lang="en-US" sz="1500" b="1" dirty="0">
-                <a:solidFill>
-                  <a:srgbClr val="151A21"/>
-                </a:solidFill>
-                <a:latin typeface="Arial" pitchFamily="34" charset="0"/>
-                <a:ea typeface="Arial" pitchFamily="34" charset="-122"/>
-                <a:cs typeface="Arial" pitchFamily="34" charset="-120"/>
-              </a:rPr>
-              <a:t>Pilot / proof of value</a:t>
-            </a:r>
-            <a:endParaRPr lang="en-US" sz="1500" dirty="0"/>
-          </a:p>
-        </p:txBody>
-      </p:sp>
-      <p:sp>
-        <p:nvSpPr>
-          <p:cNvPr id="16" name="Text 11"/>
-          <p:cNvSpPr txBox="1"/>
-          <p:nvPr/>
-        </p:nvSpPr>
-        <p:spPr>
-          <a:xfrm>
-            <a:off x="3390824" y="3108960"/>
-            <a:ext cx="2567864" cy="914400"/>
-          </a:xfrm>
-          <a:prstGeom prst="rect">
-            <a:avLst/>
-          </a:prstGeom>
-          <a:noFill/>
-          <a:ln/>
-        </p:spPr>
-        <p:txBody>
-          <a:bodyPr wrap="square" lIns="0" tIns="0" rIns="0" bIns="0" rtlCol="0" anchor="t"/>
-          <a:lstStyle/>
-          <a:p>
-            <a:pPr marL="0" indent="0">
-              <a:buNone/>
-            </a:pPr>
-            <a:r>
-              <a:rPr lang="en-US" sz="1200" dirty="0">
-                <a:solidFill>
-                  <a:srgbClr val="5E6978"/>
-                </a:solidFill>
-                <a:latin typeface="Calibri" pitchFamily="34" charset="0"/>
-                <a:ea typeface="Calibri" pitchFamily="34" charset="-122"/>
-                <a:cs typeface="Calibri" pitchFamily="34" charset="-120"/>
-              </a:rPr>
-              <a:t>Deploy Falcon on a representative group of endpoints and review detections together.</a:t>
-            </a:r>
-            <a:endParaRPr lang="en-US" sz="1200" dirty="0"/>
-          </a:p>
-        </p:txBody>
-      </p:sp>
-      <p:sp>
-        <p:nvSpPr>
-          <p:cNvPr id="17" name="Text 12"/>
-          <p:cNvSpPr txBox="1"/>
-          <p:nvPr/>
-        </p:nvSpPr>
-        <p:spPr>
-          <a:xfrm>
-            <a:off x="6233008" y="1691640"/>
-            <a:ext cx="1097280" cy="731520"/>
-          </a:xfrm>
-          <a:prstGeom prst="rect">
-            <a:avLst/>
-          </a:prstGeom>
-          <a:noFill/>
-          <a:ln/>
-        </p:spPr>
-        <p:txBody>
-          <a:bodyPr wrap="square" lIns="0" tIns="0" rIns="0" bIns="0" rtlCol="0" anchor="ctr"/>
-          <a:lstStyle/>
-          <a:p>
-            <a:pPr marL="0" indent="0">
-              <a:buNone/>
-            </a:pPr>
-            <a:r>
-              <a:rPr lang="en-US" sz="4400" b="1" dirty="0">
-                <a:solidFill>
-                  <a:srgbClr val="D5DAE1"/>
-                </a:solidFill>
-                <a:latin typeface="Arial" pitchFamily="34" charset="0"/>
-                <a:ea typeface="Arial" pitchFamily="34" charset="-122"/>
-                <a:cs typeface="Arial" pitchFamily="34" charset="-120"/>
-              </a:rPr>
-              <a:t>03</a:t>
-            </a:r>
-            <a:endParaRPr lang="en-US" sz="4400" dirty="0"/>
-          </a:p>
-        </p:txBody>
-      </p:sp>
-      <p:sp>
-        <p:nvSpPr>
-          <p:cNvPr id="18" name="Shape 13"/>
-          <p:cNvSpPr/>
-          <p:nvPr/>
-        </p:nvSpPr>
-        <p:spPr>
-          <a:xfrm>
-            <a:off x="8233943" y="1801368"/>
-            <a:ext cx="512064" cy="512064"/>
-          </a:xfrm>
-          <a:prstGeom prst="roundRect">
-            <a:avLst>
-              <a:gd name="adj" fmla="val 17857"/>
-            </a:avLst>
-          </a:prstGeom>
-          <a:solidFill>
-            <a:srgbClr val="EAEEF3"/>
-          </a:solidFill>
-          <a:ln w="12700">
-            <a:solidFill>
-              <a:srgbClr val="EAEEF3"/>
-            </a:solidFill>
-            <a:prstDash val="solid"/>
-          </a:ln>
-        </p:spPr>
-      </p:sp>
-      <p:pic>
-        <p:nvPicPr>
-          <p:cNvPr id="19" name="Image 3" descr="preencoded.png"/>
-          <p:cNvPicPr>
-            <a:picLocks noChangeAspect="1"/>
-          </p:cNvPicPr>
-          <p:nvPr/>
-        </p:nvPicPr>
-        <p:blipFill>
-          <a:blip r:embed="rId6"/>
-          <a:stretch>
-            <a:fillRect/>
-          </a:stretch>
-        </p:blipFill>
-        <p:spPr>
-          <a:xfrm>
-            <a:off x="8346597" y="1914022"/>
-            <a:ext cx="286756" cy="286756"/>
-          </a:xfrm>
-          <a:prstGeom prst="rect">
-            <a:avLst/>
-          </a:prstGeom>
-        </p:spPr>
-      </p:pic>
-      <p:sp>
-        <p:nvSpPr>
-          <p:cNvPr id="20" name="Shape 14"/>
-          <p:cNvSpPr/>
-          <p:nvPr/>
-        </p:nvSpPr>
-        <p:spPr>
-          <a:xfrm>
-            <a:off x="6233008" y="2587752"/>
-            <a:ext cx="2567864" cy="0"/>
-          </a:xfrm>
-          <a:prstGeom prst="line">
-            <a:avLst/>
-          </a:prstGeom>
-          <a:noFill/>
-          <a:ln w="25400">
-            <a:solidFill>
-              <a:srgbClr val="DCE1E7"/>
-            </a:solidFill>
-            <a:prstDash val="solid"/>
-          </a:ln>
-        </p:spPr>
-      </p:sp>
-      <p:sp>
-        <p:nvSpPr>
-          <p:cNvPr id="21" name="Text 15"/>
-          <p:cNvSpPr txBox="1"/>
-          <p:nvPr/>
-        </p:nvSpPr>
-        <p:spPr>
-          <a:xfrm>
-            <a:off x="6233008" y="2743200"/>
-            <a:ext cx="2567864" cy="329184"/>
-          </a:xfrm>
-          <a:prstGeom prst="rect">
-            <a:avLst/>
-          </a:prstGeom>
-          <a:noFill/>
-          <a:ln/>
-        </p:spPr>
-        <p:txBody>
-          <a:bodyPr wrap="square" lIns="0" tIns="0" rIns="0" bIns="0" rtlCol="0" anchor="t"/>
-          <a:lstStyle/>
-          <a:p>
-            <a:pPr marL="0" indent="0">
-              <a:buNone/>
-            </a:pPr>
-            <a:r>
-              <a:rPr lang="en-US" sz="1500" b="1" dirty="0">
-                <a:solidFill>
-                  <a:srgbClr val="151A21"/>
-                </a:solidFill>
-                <a:latin typeface="Arial" pitchFamily="34" charset="0"/>
-                <a:ea typeface="Arial" pitchFamily="34" charset="-122"/>
-                <a:cs typeface="Arial" pitchFamily="34" charset="-120"/>
-              </a:rPr>
-              <a:t>Results review</a:t>
-            </a:r>
-            <a:endParaRPr lang="en-US" sz="1500" dirty="0"/>
-          </a:p>
-        </p:txBody>
-      </p:sp>
-      <p:sp>
-        <p:nvSpPr>
-          <p:cNvPr id="22" name="Text 16"/>
-          <p:cNvSpPr txBox="1"/>
-          <p:nvPr/>
-        </p:nvSpPr>
-        <p:spPr>
-          <a:xfrm>
-            <a:off x="6233008" y="3108960"/>
-            <a:ext cx="2567864" cy="914400"/>
-          </a:xfrm>
-          <a:prstGeom prst="rect">
-            <a:avLst/>
-          </a:prstGeom>
-          <a:noFill/>
-          <a:ln/>
-        </p:spPr>
-        <p:txBody>
-          <a:bodyPr wrap="square" lIns="0" tIns="0" rIns="0" bIns="0" rtlCol="0" anchor="t"/>
-          <a:lstStyle/>
-          <a:p>
-            <a:pPr marL="0" indent="0">
-              <a:buNone/>
-            </a:pPr>
-            <a:r>
-              <a:rPr lang="en-US" sz="1200" dirty="0">
-                <a:solidFill>
-                  <a:srgbClr val="5E6978"/>
-                </a:solidFill>
-                <a:latin typeface="Calibri" pitchFamily="34" charset="0"/>
-                <a:ea typeface="Calibri" pitchFamily="34" charset="-122"/>
-                <a:cs typeface="Calibri" pitchFamily="34" charset="-120"/>
-              </a:rPr>
-              <a:t>Share pilot findings and confirm the final deployment scope and schedule.</a:t>
-            </a:r>
-            <a:endParaRPr lang="en-US" sz="1200" dirty="0"/>
-          </a:p>
-        </p:txBody>
-      </p:sp>
-      <p:sp>
-        <p:nvSpPr>
-          <p:cNvPr id="23" name="Text 17"/>
-          <p:cNvSpPr txBox="1"/>
-          <p:nvPr/>
-        </p:nvSpPr>
-        <p:spPr>
-          <a:xfrm>
-            <a:off x="9075191" y="1691640"/>
-            <a:ext cx="1097280" cy="731520"/>
-          </a:xfrm>
-          <a:prstGeom prst="rect">
-            <a:avLst/>
-          </a:prstGeom>
-          <a:noFill/>
-          <a:ln/>
-        </p:spPr>
-        <p:txBody>
-          <a:bodyPr wrap="square" lIns="0" tIns="0" rIns="0" bIns="0" rtlCol="0" anchor="ctr"/>
-          <a:lstStyle/>
-          <a:p>
-            <a:pPr marL="0" indent="0">
-              <a:buNone/>
-            </a:pPr>
-            <a:r>
-              <a:rPr lang="en-US" sz="4400" b="1" dirty="0">
-                <a:solidFill>
-                  <a:srgbClr val="D5DAE1"/>
-                </a:solidFill>
-                <a:latin typeface="Arial" pitchFamily="34" charset="0"/>
-                <a:ea typeface="Arial" pitchFamily="34" charset="-122"/>
-                <a:cs typeface="Arial" pitchFamily="34" charset="-120"/>
-              </a:rPr>
-              <a:t>04</a:t>
-            </a:r>
-            <a:endParaRPr lang="en-US" sz="4400" dirty="0"/>
-          </a:p>
-        </p:txBody>
-      </p:sp>
-      <p:sp>
-        <p:nvSpPr>
-          <p:cNvPr id="24" name="Shape 18"/>
-          <p:cNvSpPr/>
-          <p:nvPr/>
-        </p:nvSpPr>
-        <p:spPr>
-          <a:xfrm>
-            <a:off x="11076127" y="1801368"/>
-            <a:ext cx="512064" cy="512064"/>
-          </a:xfrm>
-          <a:prstGeom prst="roundRect">
-            <a:avLst>
-              <a:gd name="adj" fmla="val 17857"/>
-            </a:avLst>
-          </a:prstGeom>
-          <a:solidFill>
-            <a:srgbClr val="EAEEF3"/>
-          </a:solidFill>
-          <a:ln w="12700">
-            <a:solidFill>
-              <a:srgbClr val="EAEEF3"/>
-            </a:solidFill>
-            <a:prstDash val="solid"/>
-          </a:ln>
-        </p:spPr>
-      </p:sp>
-      <p:pic>
-        <p:nvPicPr>
-          <p:cNvPr id="25" name="Image 4" descr="preencoded.png"/>
-          <p:cNvPicPr>
-            <a:picLocks noChangeAspect="1"/>
-          </p:cNvPicPr>
-          <p:nvPr/>
-        </p:nvPicPr>
-        <p:blipFill>
-          <a:blip r:embed="rId7"/>
-          <a:stretch>
-            <a:fillRect/>
-          </a:stretch>
-        </p:blipFill>
-        <p:spPr>
-          <a:xfrm>
-            <a:off x="11188781" y="1914022"/>
-            <a:ext cx="286756" cy="286756"/>
-          </a:xfrm>
-          <a:prstGeom prst="rect">
-            <a:avLst/>
-          </a:prstGeom>
-        </p:spPr>
-      </p:pic>
-      <p:sp>
-        <p:nvSpPr>
-          <p:cNvPr id="26" name="Shape 19"/>
-          <p:cNvSpPr/>
-          <p:nvPr/>
-        </p:nvSpPr>
-        <p:spPr>
-          <a:xfrm>
-            <a:off x="9075191" y="2587752"/>
-            <a:ext cx="2567864" cy="0"/>
-          </a:xfrm>
-          <a:prstGeom prst="line">
-            <a:avLst/>
-          </a:prstGeom>
-          <a:noFill/>
-          <a:ln w="25400">
-            <a:solidFill>
-              <a:srgbClr val="DCE1E7"/>
-            </a:solidFill>
-            <a:prstDash val="solid"/>
-          </a:ln>
-        </p:spPr>
-      </p:sp>
-      <p:sp>
-        <p:nvSpPr>
-          <p:cNvPr id="27" name="Text 20"/>
-          <p:cNvSpPr txBox="1"/>
-          <p:nvPr/>
-        </p:nvSpPr>
-        <p:spPr>
-          <a:xfrm>
-            <a:off x="9075191" y="2743200"/>
-            <a:ext cx="2567864" cy="329184"/>
-          </a:xfrm>
-          <a:prstGeom prst="rect">
-            <a:avLst/>
-          </a:prstGeom>
-          <a:noFill/>
-          <a:ln/>
-        </p:spPr>
-        <p:txBody>
-          <a:bodyPr wrap="square" lIns="0" tIns="0" rIns="0" bIns="0" rtlCol="0" anchor="t"/>
-          <a:lstStyle/>
-          <a:p>
-            <a:pPr marL="0" indent="0">
-              <a:buNone/>
-            </a:pPr>
-            <a:r>
-              <a:rPr lang="en-US" sz="1500" b="1" dirty="0">
-                <a:solidFill>
-                  <a:srgbClr val="151A21"/>
-                </a:solidFill>
-                <a:latin typeface="Arial" pitchFamily="34" charset="0"/>
-                <a:ea typeface="Arial" pitchFamily="34" charset="-122"/>
-                <a:cs typeface="Arial" pitchFamily="34" charset="-120"/>
-              </a:rPr>
-              <a:t>Rollout</a:t>
-            </a:r>
-            <a:endParaRPr lang="en-US" sz="1500" dirty="0"/>
-          </a:p>
-        </p:txBody>
-      </p:sp>
-      <p:sp>
-        <p:nvSpPr>
-          <p:cNvPr id="28" name="Text 21"/>
-          <p:cNvSpPr txBox="1"/>
-          <p:nvPr/>
-        </p:nvSpPr>
-        <p:spPr>
-          <a:xfrm>
-            <a:off x="9075191" y="3108960"/>
-            <a:ext cx="2567864" cy="914400"/>
-          </a:xfrm>
-          <a:prstGeom prst="rect">
-            <a:avLst/>
-          </a:prstGeom>
-          <a:noFill/>
-          <a:ln/>
-        </p:spPr>
-        <p:txBody>
-          <a:bodyPr wrap="square" lIns="0" tIns="0" rIns="0" bIns="0" rtlCol="0" anchor="t"/>
-          <a:lstStyle/>
-          <a:p>
-            <a:pPr marL="0" indent="0">
-              <a:buNone/>
-            </a:pPr>
-            <a:r>
-              <a:rPr lang="en-US" sz="1200" dirty="0">
-                <a:solidFill>
-                  <a:srgbClr val="5E6978"/>
-                </a:solidFill>
-                <a:latin typeface="Calibri" pitchFamily="34" charset="0"/>
-                <a:ea typeface="Calibri" pitchFamily="34" charset="-122"/>
-                <a:cs typeface="Calibri" pitchFamily="34" charset="-120"/>
-              </a:rPr>
-              <a:t>Full deployment following the phased roadmap, with ongoing SECUKOREA technical support and reporting.</a:t>
-            </a:r>
-            <a:endParaRPr lang="en-US" sz="1200" dirty="0"/>
-          </a:p>
-        </p:txBody>
-      </p:sp>
-      <p:sp>
-        <p:nvSpPr>
-          <p:cNvPr id="29" name="Shape 22"/>
-          <p:cNvSpPr/>
-          <p:nvPr/>
-        </p:nvSpPr>
-        <p:spPr>
-          <a:xfrm>
-            <a:off x="548640" y="4343400"/>
-            <a:ext cx="11094415" cy="1554480"/>
-          </a:xfrm>
-          <a:prstGeom prst="rect">
-            <a:avLst/>
-          </a:prstGeom>
-          <a:solidFill>
-            <a:srgbClr val="000000"/>
-          </a:solidFill>
-          <a:ln w="12700">
-            <a:solidFill>
-              <a:srgbClr val="000000"/>
-            </a:solidFill>
-            <a:prstDash val="solid"/>
-          </a:ln>
-        </p:spPr>
-      </p:sp>
-      <p:pic>
-        <p:nvPicPr>
-          <p:cNvPr id="30" name="Image 5" descr="/private/tmp/claude-501/-Users-jihanvin-Desktop-NIVNAH-AI/16a96446-d9b3-40e2-af9e-a3011ae3db84/scratchpad/assets/bg_redwave.jpg"/>
-          <p:cNvPicPr>
-            <a:picLocks noChangeAspect="1"/>
-          </p:cNvPicPr>
-          <p:nvPr/>
-        </p:nvPicPr>
-        <p:blipFill>
-          <a:blip r:embed="rId8"/>
-          <a:srcRect/>
-          <a:stretch/>
-        </p:blipFill>
-        <p:spPr>
-          <a:xfrm>
-            <a:off x="7528255" y="4343400"/>
-            <a:ext cx="4114800" cy="1554480"/>
-          </a:xfrm>
-          <a:prstGeom prst="rect">
-            <a:avLst/>
-          </a:prstGeom>
-        </p:spPr>
-      </p:pic>
-      <p:sp>
-        <p:nvSpPr>
-          <p:cNvPr id="31" name="Text 23"/>
-          <p:cNvSpPr txBox="1"/>
-          <p:nvPr/>
-        </p:nvSpPr>
-        <p:spPr>
-          <a:xfrm>
-            <a:off x="960120" y="4572000"/>
-            <a:ext cx="6400800" cy="237744"/>
-          </a:xfrm>
-          <a:prstGeom prst="rect">
-            <a:avLst/>
-          </a:prstGeom>
-          <a:noFill/>
-          <a:ln/>
-        </p:spPr>
-        <p:txBody>
-          <a:bodyPr wrap="square" lIns="0" tIns="0" rIns="0" bIns="0" rtlCol="0" anchor="t"/>
-          <a:lstStyle/>
-          <a:p>
-            <a:pPr marL="0" indent="0">
-              <a:buNone/>
-            </a:pPr>
-            <a:r>
-              <a:rPr lang="en-US" sz="1000" b="1" kern="0" spc="200" dirty="0">
-                <a:solidFill>
-                  <a:srgbClr val="E3202A"/>
-                </a:solidFill>
-                <a:latin typeface="Calibri" pitchFamily="34" charset="0"/>
-                <a:ea typeface="Calibri" pitchFamily="34" charset="-122"/>
-                <a:cs typeface="Calibri" pitchFamily="34" charset="-120"/>
-              </a:rPr>
-              <a:t>FIRST STEP</a:t>
-            </a:r>
-            <a:endParaRPr lang="en-US" sz="1000" dirty="0"/>
-          </a:p>
-        </p:txBody>
-      </p:sp>
-      <p:sp>
-        <p:nvSpPr>
-          <p:cNvPr id="32" name="Text 24"/>
-          <p:cNvSpPr txBox="1"/>
-          <p:nvPr/>
-        </p:nvSpPr>
-        <p:spPr>
-          <a:xfrm>
-            <a:off x="960120" y="4846320"/>
-            <a:ext cx="6766560" cy="868680"/>
-          </a:xfrm>
-          <a:prstGeom prst="rect">
-            <a:avLst/>
-          </a:prstGeom>
-          <a:noFill/>
-          <a:ln/>
-        </p:spPr>
-        <p:txBody>
-          <a:bodyPr wrap="square" lIns="0" tIns="0" rIns="0" bIns="0" rtlCol="0" anchor="ctr"/>
-          <a:lstStyle/>
-          <a:p>
-            <a:pPr marL="0" indent="0">
-              <a:buNone/>
-            </a:pPr>
-            <a:r>
-              <a:rPr lang="en-US" sz="1800" b="1" dirty="0">
-                <a:solidFill>
-                  <a:srgbClr val="FFFFFF"/>
-                </a:solidFill>
-                <a:latin typeface="Arial" pitchFamily="34" charset="0"/>
-                <a:ea typeface="Arial" pitchFamily="34" charset="-122"/>
-                <a:cs typeface="Arial" pitchFamily="34" charset="-120"/>
-              </a:rPr>
-              <a:t>Let's schedule a 1-hour scoping workshop to confirm the endpoint scope and pilot group.</a:t>
-            </a:r>
-            <a:endParaRPr lang="en-US" sz="1800" dirty="0"/>
-          </a:p>
-        </p:txBody>
-      </p:sp>
-      <p:sp>
-        <p:nvSpPr>
-          <p:cNvPr id="33" name="Text 25"/>
-          <p:cNvSpPr txBox="1"/>
-          <p:nvPr/>
-        </p:nvSpPr>
-        <p:spPr>
-          <a:xfrm>
-            <a:off x="548640" y="6446520"/>
-            <a:ext cx="7315200" cy="219456"/>
-          </a:xfrm>
-          <a:prstGeom prst="rect">
-            <a:avLst/>
-          </a:prstGeom>
-          <a:noFill/>
-          <a:ln/>
-        </p:spPr>
-        <p:txBody>
-          <a:bodyPr wrap="square" lIns="0" tIns="0" rIns="0" bIns="0" rtlCol="0" anchor="ctr"/>
-          <a:lstStyle/>
-          <a:p>
-            <a:pPr marL="0" indent="0">
-              <a:buNone/>
-            </a:pPr>
-            <a:r>
-              <a:rPr lang="en-US" sz="900" dirty="0">
-                <a:solidFill>
-                  <a:srgbClr val="5E6978"/>
-                </a:solidFill>
-                <a:latin typeface="Calibri" pitchFamily="34" charset="0"/>
-                <a:ea typeface="Calibri" pitchFamily="34" charset="-122"/>
-                <a:cs typeface="Calibri" pitchFamily="34" charset="-120"/>
-              </a:rPr>
-              <a:t>19   |   Nessus vs. CrowdStrike Falcon Platform  ·  Proposal for The Westin Resort Guam</a:t>
-            </a:r>
-            <a:endParaRPr lang="en-US" sz="900" dirty="0"/>
-          </a:p>
-        </p:txBody>
-      </p:sp>
-      <p:pic>
-        <p:nvPicPr>
-          <p:cNvPr id="34" name="Image 6" descr="/private/tmp/claude-501/-Users-jihanvin-Desktop-NIVNAH-AI/16a96446-d9b3-40e2-af9e-a3011ae3db84/scratchpad/assets/secukorea_dark.png"/>
-          <p:cNvPicPr>
-            <a:picLocks noChangeAspect="1"/>
-          </p:cNvPicPr>
-          <p:nvPr/>
-        </p:nvPicPr>
-        <p:blipFill>
-          <a:blip r:embed="rId9"/>
           <a:stretch>
             <a:fillRect/>
           </a:stretch>

</xml_diff>